<commit_message>
nora updates from stevescomputer
</commit_message>
<xml_diff>
--- a/MindwalkJul2026.pptx
+++ b/MindwalkJul2026.pptx
@@ -5,10 +5,22 @@
     <p:sldMasterId id="2147483648" r:id="rId1"/>
   </p:sldMasterIdLst>
   <p:sldIdLst>
-    <p:sldId id="256" r:id="rId2"/>
-    <p:sldId id="257" r:id="rId3"/>
-    <p:sldId id="258" r:id="rId4"/>
-    <p:sldId id="259" r:id="rId5"/>
+    <p:sldId id="263" r:id="rId2"/>
+    <p:sldId id="264" r:id="rId3"/>
+    <p:sldId id="265" r:id="rId4"/>
+    <p:sldId id="266" r:id="rId5"/>
+    <p:sldId id="271" r:id="rId6"/>
+    <p:sldId id="267" r:id="rId7"/>
+    <p:sldId id="268" r:id="rId8"/>
+    <p:sldId id="269" r:id="rId9"/>
+    <p:sldId id="270" r:id="rId10"/>
+    <p:sldId id="261" r:id="rId11"/>
+    <p:sldId id="260" r:id="rId12"/>
+    <p:sldId id="262" r:id="rId13"/>
+    <p:sldId id="256" r:id="rId14"/>
+    <p:sldId id="257" r:id="rId15"/>
+    <p:sldId id="258" r:id="rId16"/>
+    <p:sldId id="259" r:id="rId17"/>
   </p:sldIdLst>
   <p:sldSz cx="12192000" cy="6858000"/>
   <p:notesSz cx="6858000" cy="9144000"/>
@@ -107,6 +119,11 @@
       </a:defRPr>
     </a:lvl9pPr>
   </p:defaultTextStyle>
+  <p:extLst>
+    <p:ext uri="{EFAFB233-063F-42B5-8137-9DF3F51BA10A}">
+      <p15:sldGuideLst xmlns:p15="http://schemas.microsoft.com/office/powerpoint/2012/main"/>
+    </p:ext>
+  </p:extLst>
 </p:presentation>
 </file>
 
@@ -3324,62 +3341,12 @@
           <a:chExt cx="0" cy="0"/>
         </a:xfrm>
       </p:grpSpPr>
-      <p:sp>
-        <p:nvSpPr>
-          <p:cNvPr id="2" name="Title 1">
-            <a:extLst>
-              <a:ext uri="{FF2B5EF4-FFF2-40B4-BE49-F238E27FC236}">
-                <a16:creationId xmlns:a16="http://schemas.microsoft.com/office/drawing/2014/main" id="{27999D66-E9F1-6F6E-7082-1434E9BDC057}"/>
-              </a:ext>
-            </a:extLst>
-          </p:cNvPr>
-          <p:cNvSpPr>
-            <a:spLocks noGrp="1"/>
-          </p:cNvSpPr>
-          <p:nvPr>
-            <p:ph type="ctrTitle"/>
-          </p:nvPr>
-        </p:nvSpPr>
-        <p:spPr/>
-        <p:txBody>
-          <a:bodyPr/>
-          <a:lstStyle/>
-          <a:p>
-            <a:endParaRPr lang="en-US"/>
-          </a:p>
-        </p:txBody>
-      </p:sp>
-      <p:sp>
-        <p:nvSpPr>
-          <p:cNvPr id="3" name="Subtitle 2">
-            <a:extLst>
-              <a:ext uri="{FF2B5EF4-FFF2-40B4-BE49-F238E27FC236}">
-                <a16:creationId xmlns:a16="http://schemas.microsoft.com/office/drawing/2014/main" id="{B11CEF0C-70CD-A57A-1CCA-AC1AF937FA30}"/>
-              </a:ext>
-            </a:extLst>
-          </p:cNvPr>
-          <p:cNvSpPr>
-            <a:spLocks noGrp="1"/>
-          </p:cNvSpPr>
-          <p:nvPr>
-            <p:ph type="subTitle" idx="1"/>
-          </p:nvPr>
-        </p:nvSpPr>
-        <p:spPr/>
-        <p:txBody>
-          <a:bodyPr/>
-          <a:lstStyle/>
-          <a:p>
-            <a:endParaRPr lang="en-US"/>
-          </a:p>
-        </p:txBody>
-      </p:sp>
       <p:pic>
         <p:nvPicPr>
           <p:cNvPr id="5" name="Picture 4">
             <a:extLst>
               <a:ext uri="{FF2B5EF4-FFF2-40B4-BE49-F238E27FC236}">
-                <a16:creationId xmlns:a16="http://schemas.microsoft.com/office/drawing/2014/main" id="{07944D88-8CAA-BC2D-B6A9-E2B1BAE8DAD9}"/>
+                <a16:creationId xmlns:a16="http://schemas.microsoft.com/office/drawing/2014/main" id="{118513DA-3F31-FC2F-6A01-F659CB64CD4E}"/>
               </a:ext>
             </a:extLst>
           </p:cNvPr>
@@ -3396,6 +3363,296 @@
         </p:blipFill>
         <p:spPr>
           <a:xfrm>
+            <a:off x="2490191" y="945875"/>
+            <a:ext cx="6596473" cy="4966249"/>
+          </a:xfrm>
+          <a:prstGeom prst="rect">
+            <a:avLst/>
+          </a:prstGeom>
+        </p:spPr>
+      </p:pic>
+    </p:spTree>
+    <p:extLst>
+      <p:ext uri="{BB962C8B-B14F-4D97-AF65-F5344CB8AC3E}">
+        <p14:creationId xmlns:p14="http://schemas.microsoft.com/office/powerpoint/2010/main" val="2514661185"/>
+      </p:ext>
+    </p:extLst>
+  </p:cSld>
+  <p:clrMapOvr>
+    <a:masterClrMapping/>
+  </p:clrMapOvr>
+</p:sld>
+</file>
+
+<file path=ppt/slides/slide10.xml><?xml version="1.0" encoding="utf-8"?>
+<p:sld xmlns:a="http://schemas.openxmlformats.org/drawingml/2006/main" xmlns:r="http://schemas.openxmlformats.org/officeDocument/2006/relationships" xmlns:p="http://schemas.openxmlformats.org/presentationml/2006/main">
+  <p:cSld>
+    <p:spTree>
+      <p:nvGrpSpPr>
+        <p:cNvPr id="1" name=""/>
+        <p:cNvGrpSpPr/>
+        <p:nvPr/>
+      </p:nvGrpSpPr>
+      <p:grpSpPr>
+        <a:xfrm>
+          <a:off x="0" y="0"/>
+          <a:ext cx="0" cy="0"/>
+          <a:chOff x="0" y="0"/>
+          <a:chExt cx="0" cy="0"/>
+        </a:xfrm>
+      </p:grpSpPr>
+      <p:pic>
+        <p:nvPicPr>
+          <p:cNvPr id="3" name="Picture 2">
+            <a:extLst>
+              <a:ext uri="{FF2B5EF4-FFF2-40B4-BE49-F238E27FC236}">
+                <a16:creationId xmlns:a16="http://schemas.microsoft.com/office/drawing/2014/main" id="{3A1A0F0F-C084-3B8C-C0E4-E31D48C5FB29}"/>
+              </a:ext>
+            </a:extLst>
+          </p:cNvPr>
+          <p:cNvPicPr>
+            <a:picLocks noChangeAspect="1"/>
+          </p:cNvPicPr>
+          <p:nvPr/>
+        </p:nvPicPr>
+        <p:blipFill>
+          <a:blip r:embed="rId2"/>
+          <a:stretch>
+            <a:fillRect/>
+          </a:stretch>
+        </p:blipFill>
+        <p:spPr>
+          <a:xfrm>
+            <a:off x="85898" y="116378"/>
+            <a:ext cx="12020204" cy="6264336"/>
+          </a:xfrm>
+          <a:prstGeom prst="rect">
+            <a:avLst/>
+          </a:prstGeom>
+        </p:spPr>
+      </p:pic>
+    </p:spTree>
+    <p:extLst>
+      <p:ext uri="{BB962C8B-B14F-4D97-AF65-F5344CB8AC3E}">
+        <p14:creationId xmlns:p14="http://schemas.microsoft.com/office/powerpoint/2010/main" val="1614044342"/>
+      </p:ext>
+    </p:extLst>
+  </p:cSld>
+  <p:clrMapOvr>
+    <a:masterClrMapping/>
+  </p:clrMapOvr>
+</p:sld>
+</file>
+
+<file path=ppt/slides/slide11.xml><?xml version="1.0" encoding="utf-8"?>
+<p:sld xmlns:a="http://schemas.openxmlformats.org/drawingml/2006/main" xmlns:r="http://schemas.openxmlformats.org/officeDocument/2006/relationships" xmlns:p="http://schemas.openxmlformats.org/presentationml/2006/main">
+  <p:cSld>
+    <p:spTree>
+      <p:nvGrpSpPr>
+        <p:cNvPr id="1" name=""/>
+        <p:cNvGrpSpPr/>
+        <p:nvPr/>
+      </p:nvGrpSpPr>
+      <p:grpSpPr>
+        <a:xfrm>
+          <a:off x="0" y="0"/>
+          <a:ext cx="0" cy="0"/>
+          <a:chOff x="0" y="0"/>
+          <a:chExt cx="0" cy="0"/>
+        </a:xfrm>
+      </p:grpSpPr>
+      <p:pic>
+        <p:nvPicPr>
+          <p:cNvPr id="3" name="Picture 2">
+            <a:extLst>
+              <a:ext uri="{FF2B5EF4-FFF2-40B4-BE49-F238E27FC236}">
+                <a16:creationId xmlns:a16="http://schemas.microsoft.com/office/drawing/2014/main" id="{54867AD9-CA7B-89DB-84DE-AB61B9BDB7FE}"/>
+              </a:ext>
+            </a:extLst>
+          </p:cNvPr>
+          <p:cNvPicPr>
+            <a:picLocks noChangeAspect="1"/>
+          </p:cNvPicPr>
+          <p:nvPr/>
+        </p:nvPicPr>
+        <p:blipFill>
+          <a:blip r:embed="rId2"/>
+          <a:stretch>
+            <a:fillRect/>
+          </a:stretch>
+        </p:blipFill>
+        <p:spPr>
+          <a:xfrm>
+            <a:off x="505690" y="0"/>
+            <a:ext cx="11030989" cy="6627786"/>
+          </a:xfrm>
+          <a:prstGeom prst="rect">
+            <a:avLst/>
+          </a:prstGeom>
+        </p:spPr>
+      </p:pic>
+    </p:spTree>
+    <p:extLst>
+      <p:ext uri="{BB962C8B-B14F-4D97-AF65-F5344CB8AC3E}">
+        <p14:creationId xmlns:p14="http://schemas.microsoft.com/office/powerpoint/2010/main" val="3061011095"/>
+      </p:ext>
+    </p:extLst>
+  </p:cSld>
+  <p:clrMapOvr>
+    <a:masterClrMapping/>
+  </p:clrMapOvr>
+</p:sld>
+</file>
+
+<file path=ppt/slides/slide12.xml><?xml version="1.0" encoding="utf-8"?>
+<p:sld xmlns:a="http://schemas.openxmlformats.org/drawingml/2006/main" xmlns:r="http://schemas.openxmlformats.org/officeDocument/2006/relationships" xmlns:p="http://schemas.openxmlformats.org/presentationml/2006/main">
+  <p:cSld>
+    <p:spTree>
+      <p:nvGrpSpPr>
+        <p:cNvPr id="1" name=""/>
+        <p:cNvGrpSpPr/>
+        <p:nvPr/>
+      </p:nvGrpSpPr>
+      <p:grpSpPr>
+        <a:xfrm>
+          <a:off x="0" y="0"/>
+          <a:ext cx="0" cy="0"/>
+          <a:chOff x="0" y="0"/>
+          <a:chExt cx="0" cy="0"/>
+        </a:xfrm>
+      </p:grpSpPr>
+      <p:pic>
+        <p:nvPicPr>
+          <p:cNvPr id="3" name="Picture 2">
+            <a:extLst>
+              <a:ext uri="{FF2B5EF4-FFF2-40B4-BE49-F238E27FC236}">
+                <a16:creationId xmlns:a16="http://schemas.microsoft.com/office/drawing/2014/main" id="{3D4B5EE6-85D8-D281-0541-BBE5F6AE4F17}"/>
+              </a:ext>
+            </a:extLst>
+          </p:cNvPr>
+          <p:cNvPicPr>
+            <a:picLocks noChangeAspect="1"/>
+          </p:cNvPicPr>
+          <p:nvPr/>
+        </p:nvPicPr>
+        <p:blipFill>
+          <a:blip r:embed="rId2"/>
+          <a:stretch>
+            <a:fillRect/>
+          </a:stretch>
+        </p:blipFill>
+        <p:spPr>
+          <a:xfrm>
+            <a:off x="648393" y="83236"/>
+            <a:ext cx="11155680" cy="6691528"/>
+          </a:xfrm>
+          <a:prstGeom prst="rect">
+            <a:avLst/>
+          </a:prstGeom>
+        </p:spPr>
+      </p:pic>
+    </p:spTree>
+    <p:extLst>
+      <p:ext uri="{BB962C8B-B14F-4D97-AF65-F5344CB8AC3E}">
+        <p14:creationId xmlns:p14="http://schemas.microsoft.com/office/powerpoint/2010/main" val="1267412039"/>
+      </p:ext>
+    </p:extLst>
+  </p:cSld>
+  <p:clrMapOvr>
+    <a:masterClrMapping/>
+  </p:clrMapOvr>
+</p:sld>
+</file>
+
+<file path=ppt/slides/slide13.xml><?xml version="1.0" encoding="utf-8"?>
+<p:sld xmlns:a="http://schemas.openxmlformats.org/drawingml/2006/main" xmlns:r="http://schemas.openxmlformats.org/officeDocument/2006/relationships" xmlns:p="http://schemas.openxmlformats.org/presentationml/2006/main">
+  <p:cSld>
+    <p:spTree>
+      <p:nvGrpSpPr>
+        <p:cNvPr id="1" name=""/>
+        <p:cNvGrpSpPr/>
+        <p:nvPr/>
+      </p:nvGrpSpPr>
+      <p:grpSpPr>
+        <a:xfrm>
+          <a:off x="0" y="0"/>
+          <a:ext cx="0" cy="0"/>
+          <a:chOff x="0" y="0"/>
+          <a:chExt cx="0" cy="0"/>
+        </a:xfrm>
+      </p:grpSpPr>
+      <p:sp>
+        <p:nvSpPr>
+          <p:cNvPr id="2" name="Title 1">
+            <a:extLst>
+              <a:ext uri="{FF2B5EF4-FFF2-40B4-BE49-F238E27FC236}">
+                <a16:creationId xmlns:a16="http://schemas.microsoft.com/office/drawing/2014/main" id="{27999D66-E9F1-6F6E-7082-1434E9BDC057}"/>
+              </a:ext>
+            </a:extLst>
+          </p:cNvPr>
+          <p:cNvSpPr>
+            <a:spLocks noGrp="1"/>
+          </p:cNvSpPr>
+          <p:nvPr>
+            <p:ph type="ctrTitle"/>
+          </p:nvPr>
+        </p:nvSpPr>
+        <p:spPr/>
+        <p:txBody>
+          <a:bodyPr/>
+          <a:lstStyle/>
+          <a:p>
+            <a:endParaRPr lang="en-US"/>
+          </a:p>
+        </p:txBody>
+      </p:sp>
+      <p:sp>
+        <p:nvSpPr>
+          <p:cNvPr id="3" name="Subtitle 2">
+            <a:extLst>
+              <a:ext uri="{FF2B5EF4-FFF2-40B4-BE49-F238E27FC236}">
+                <a16:creationId xmlns:a16="http://schemas.microsoft.com/office/drawing/2014/main" id="{B11CEF0C-70CD-A57A-1CCA-AC1AF937FA30}"/>
+              </a:ext>
+            </a:extLst>
+          </p:cNvPr>
+          <p:cNvSpPr>
+            <a:spLocks noGrp="1"/>
+          </p:cNvSpPr>
+          <p:nvPr>
+            <p:ph type="subTitle" idx="1"/>
+          </p:nvPr>
+        </p:nvSpPr>
+        <p:spPr/>
+        <p:txBody>
+          <a:bodyPr/>
+          <a:lstStyle/>
+          <a:p>
+            <a:endParaRPr lang="en-US"/>
+          </a:p>
+        </p:txBody>
+      </p:sp>
+      <p:pic>
+        <p:nvPicPr>
+          <p:cNvPr id="5" name="Picture 4">
+            <a:extLst>
+              <a:ext uri="{FF2B5EF4-FFF2-40B4-BE49-F238E27FC236}">
+                <a16:creationId xmlns:a16="http://schemas.microsoft.com/office/drawing/2014/main" id="{07944D88-8CAA-BC2D-B6A9-E2B1BAE8DAD9}"/>
+              </a:ext>
+            </a:extLst>
+          </p:cNvPr>
+          <p:cNvPicPr>
+            <a:picLocks noChangeAspect="1"/>
+          </p:cNvPicPr>
+          <p:nvPr/>
+        </p:nvPicPr>
+        <p:blipFill>
+          <a:blip r:embed="rId2"/>
+          <a:stretch>
+            <a:fillRect/>
+          </a:stretch>
+        </p:blipFill>
+        <p:spPr>
+          <a:xfrm>
             <a:off x="0" y="1232798"/>
             <a:ext cx="12192000" cy="4392404"/>
           </a:xfrm>
@@ -3408,6 +3665,236 @@
     <p:extLst>
       <p:ext uri="{BB962C8B-B14F-4D97-AF65-F5344CB8AC3E}">
         <p14:creationId xmlns:p14="http://schemas.microsoft.com/office/powerpoint/2010/main" val="188174436"/>
+      </p:ext>
+    </p:extLst>
+  </p:cSld>
+  <p:clrMapOvr>
+    <a:masterClrMapping/>
+  </p:clrMapOvr>
+</p:sld>
+</file>
+
+<file path=ppt/slides/slide14.xml><?xml version="1.0" encoding="utf-8"?>
+<p:sld xmlns:a="http://schemas.openxmlformats.org/drawingml/2006/main" xmlns:r="http://schemas.openxmlformats.org/officeDocument/2006/relationships" xmlns:p="http://schemas.openxmlformats.org/presentationml/2006/main">
+  <p:cSld>
+    <p:spTree>
+      <p:nvGrpSpPr>
+        <p:cNvPr id="1" name=""/>
+        <p:cNvGrpSpPr/>
+        <p:nvPr/>
+      </p:nvGrpSpPr>
+      <p:grpSpPr>
+        <a:xfrm>
+          <a:off x="0" y="0"/>
+          <a:ext cx="0" cy="0"/>
+          <a:chOff x="0" y="0"/>
+          <a:chExt cx="0" cy="0"/>
+        </a:xfrm>
+      </p:grpSpPr>
+      <p:sp>
+        <p:nvSpPr>
+          <p:cNvPr id="2" name="Title 1">
+            <a:extLst>
+              <a:ext uri="{FF2B5EF4-FFF2-40B4-BE49-F238E27FC236}">
+                <a16:creationId xmlns:a16="http://schemas.microsoft.com/office/drawing/2014/main" id="{F8DC1311-EA87-5460-1F14-B88303849246}"/>
+              </a:ext>
+            </a:extLst>
+          </p:cNvPr>
+          <p:cNvSpPr>
+            <a:spLocks noGrp="1"/>
+          </p:cNvSpPr>
+          <p:nvPr>
+            <p:ph type="title"/>
+          </p:nvPr>
+        </p:nvSpPr>
+        <p:spPr/>
+        <p:txBody>
+          <a:bodyPr/>
+          <a:lstStyle/>
+          <a:p>
+            <a:endParaRPr lang="en-US"/>
+          </a:p>
+        </p:txBody>
+      </p:sp>
+      <p:sp>
+        <p:nvSpPr>
+          <p:cNvPr id="3" name="Content Placeholder 2">
+            <a:extLst>
+              <a:ext uri="{FF2B5EF4-FFF2-40B4-BE49-F238E27FC236}">
+                <a16:creationId xmlns:a16="http://schemas.microsoft.com/office/drawing/2014/main" id="{F1864206-33F4-FF6D-E91F-20DC1A48D332}"/>
+              </a:ext>
+            </a:extLst>
+          </p:cNvPr>
+          <p:cNvSpPr>
+            <a:spLocks noGrp="1"/>
+          </p:cNvSpPr>
+          <p:nvPr>
+            <p:ph idx="1"/>
+          </p:nvPr>
+        </p:nvSpPr>
+        <p:spPr/>
+        <p:txBody>
+          <a:bodyPr/>
+          <a:lstStyle/>
+          <a:p>
+            <a:endParaRPr lang="en-US"/>
+          </a:p>
+        </p:txBody>
+      </p:sp>
+      <p:pic>
+        <p:nvPicPr>
+          <p:cNvPr id="5" name="Picture 4">
+            <a:extLst>
+              <a:ext uri="{FF2B5EF4-FFF2-40B4-BE49-F238E27FC236}">
+                <a16:creationId xmlns:a16="http://schemas.microsoft.com/office/drawing/2014/main" id="{F02195D8-5A1A-39A0-B724-D01DB19D4BC7}"/>
+              </a:ext>
+            </a:extLst>
+          </p:cNvPr>
+          <p:cNvPicPr>
+            <a:picLocks noChangeAspect="1"/>
+          </p:cNvPicPr>
+          <p:nvPr/>
+        </p:nvPicPr>
+        <p:blipFill>
+          <a:blip r:embed="rId2"/>
+          <a:stretch>
+            <a:fillRect/>
+          </a:stretch>
+        </p:blipFill>
+        <p:spPr>
+          <a:xfrm>
+            <a:off x="108066" y="1027906"/>
+            <a:ext cx="12192000" cy="4600238"/>
+          </a:xfrm>
+          <a:prstGeom prst="rect">
+            <a:avLst/>
+          </a:prstGeom>
+        </p:spPr>
+      </p:pic>
+    </p:spTree>
+    <p:extLst>
+      <p:ext uri="{BB962C8B-B14F-4D97-AF65-F5344CB8AC3E}">
+        <p14:creationId xmlns:p14="http://schemas.microsoft.com/office/powerpoint/2010/main" val="2266987066"/>
+      </p:ext>
+    </p:extLst>
+  </p:cSld>
+  <p:clrMapOvr>
+    <a:masterClrMapping/>
+  </p:clrMapOvr>
+</p:sld>
+</file>
+
+<file path=ppt/slides/slide15.xml><?xml version="1.0" encoding="utf-8"?>
+<p:sld xmlns:a="http://schemas.openxmlformats.org/drawingml/2006/main" xmlns:r="http://schemas.openxmlformats.org/officeDocument/2006/relationships" xmlns:p="http://schemas.openxmlformats.org/presentationml/2006/main">
+  <p:cSld>
+    <p:spTree>
+      <p:nvGrpSpPr>
+        <p:cNvPr id="1" name=""/>
+        <p:cNvGrpSpPr/>
+        <p:nvPr/>
+      </p:nvGrpSpPr>
+      <p:grpSpPr>
+        <a:xfrm>
+          <a:off x="0" y="0"/>
+          <a:ext cx="0" cy="0"/>
+          <a:chOff x="0" y="0"/>
+          <a:chExt cx="0" cy="0"/>
+        </a:xfrm>
+      </p:grpSpPr>
+      <p:pic>
+        <p:nvPicPr>
+          <p:cNvPr id="3" name="Picture 2">
+            <a:extLst>
+              <a:ext uri="{FF2B5EF4-FFF2-40B4-BE49-F238E27FC236}">
+                <a16:creationId xmlns:a16="http://schemas.microsoft.com/office/drawing/2014/main" id="{AE8B3F95-6D06-5841-2036-01FB1B229380}"/>
+              </a:ext>
+            </a:extLst>
+          </p:cNvPr>
+          <p:cNvPicPr>
+            <a:picLocks noChangeAspect="1"/>
+          </p:cNvPicPr>
+          <p:nvPr/>
+        </p:nvPicPr>
+        <p:blipFill>
+          <a:blip r:embed="rId2"/>
+          <a:stretch>
+            <a:fillRect/>
+          </a:stretch>
+        </p:blipFill>
+        <p:spPr>
+          <a:xfrm>
+            <a:off x="0" y="832868"/>
+            <a:ext cx="12192000" cy="5192263"/>
+          </a:xfrm>
+          <a:prstGeom prst="rect">
+            <a:avLst/>
+          </a:prstGeom>
+        </p:spPr>
+      </p:pic>
+    </p:spTree>
+    <p:extLst>
+      <p:ext uri="{BB962C8B-B14F-4D97-AF65-F5344CB8AC3E}">
+        <p14:creationId xmlns:p14="http://schemas.microsoft.com/office/powerpoint/2010/main" val="990378249"/>
+      </p:ext>
+    </p:extLst>
+  </p:cSld>
+  <p:clrMapOvr>
+    <a:masterClrMapping/>
+  </p:clrMapOvr>
+</p:sld>
+</file>
+
+<file path=ppt/slides/slide16.xml><?xml version="1.0" encoding="utf-8"?>
+<p:sld xmlns:a="http://schemas.openxmlformats.org/drawingml/2006/main" xmlns:r="http://schemas.openxmlformats.org/officeDocument/2006/relationships" xmlns:p="http://schemas.openxmlformats.org/presentationml/2006/main">
+  <p:cSld>
+    <p:spTree>
+      <p:nvGrpSpPr>
+        <p:cNvPr id="1" name=""/>
+        <p:cNvGrpSpPr/>
+        <p:nvPr/>
+      </p:nvGrpSpPr>
+      <p:grpSpPr>
+        <a:xfrm>
+          <a:off x="0" y="0"/>
+          <a:ext cx="0" cy="0"/>
+          <a:chOff x="0" y="0"/>
+          <a:chExt cx="0" cy="0"/>
+        </a:xfrm>
+      </p:grpSpPr>
+      <p:pic>
+        <p:nvPicPr>
+          <p:cNvPr id="3" name="Picture 2">
+            <a:extLst>
+              <a:ext uri="{FF2B5EF4-FFF2-40B4-BE49-F238E27FC236}">
+                <a16:creationId xmlns:a16="http://schemas.microsoft.com/office/drawing/2014/main" id="{9EAFA21A-8A8E-E0D3-1742-3DBC572A2A3D}"/>
+              </a:ext>
+            </a:extLst>
+          </p:cNvPr>
+          <p:cNvPicPr>
+            <a:picLocks noChangeAspect="1"/>
+          </p:cNvPicPr>
+          <p:nvPr/>
+        </p:nvPicPr>
+        <p:blipFill>
+          <a:blip r:embed="rId2"/>
+          <a:stretch>
+            <a:fillRect/>
+          </a:stretch>
+        </p:blipFill>
+        <p:spPr>
+          <a:xfrm>
+            <a:off x="0" y="653447"/>
+            <a:ext cx="12192000" cy="5551106"/>
+          </a:xfrm>
+          <a:prstGeom prst="rect">
+            <a:avLst/>
+          </a:prstGeom>
+        </p:spPr>
+      </p:pic>
+    </p:spTree>
+    <p:extLst>
+      <p:ext uri="{BB962C8B-B14F-4D97-AF65-F5344CB8AC3E}">
+        <p14:creationId xmlns:p14="http://schemas.microsoft.com/office/powerpoint/2010/main" val="1615924507"/>
       </p:ext>
     </p:extLst>
   </p:cSld>
@@ -3434,62 +3921,3448 @@
           <a:chExt cx="0" cy="0"/>
         </a:xfrm>
       </p:grpSpPr>
-      <p:sp>
-        <p:nvSpPr>
-          <p:cNvPr id="2" name="Title 1">
-            <a:extLst>
-              <a:ext uri="{FF2B5EF4-FFF2-40B4-BE49-F238E27FC236}">
-                <a16:creationId xmlns:a16="http://schemas.microsoft.com/office/drawing/2014/main" id="{F8DC1311-EA87-5460-1F14-B88303849246}"/>
-              </a:ext>
-            </a:extLst>
-          </p:cNvPr>
-          <p:cNvSpPr>
-            <a:spLocks noGrp="1"/>
-          </p:cNvSpPr>
-          <p:nvPr>
-            <p:ph type="title"/>
-          </p:nvPr>
-        </p:nvSpPr>
-        <p:spPr/>
-        <p:txBody>
-          <a:bodyPr/>
-          <a:lstStyle/>
-          <a:p>
+      <p:cxnSp>
+        <p:nvCxnSpPr>
+          <p:cNvPr id="7" name="Straight Connector 6">
+            <a:extLst>
+              <a:ext uri="{FF2B5EF4-FFF2-40B4-BE49-F238E27FC236}">
+                <a16:creationId xmlns:a16="http://schemas.microsoft.com/office/drawing/2014/main" id="{84FBE59D-A56F-CCBC-236A-311D7744C8B3}"/>
+              </a:ext>
+            </a:extLst>
+          </p:cNvPr>
+          <p:cNvCxnSpPr/>
+          <p:nvPr/>
+        </p:nvCxnSpPr>
+        <p:spPr>
+          <a:xfrm>
+            <a:off x="1745674" y="3050773"/>
+            <a:ext cx="8902931" cy="0"/>
+          </a:xfrm>
+          <a:prstGeom prst="line">
+            <a:avLst/>
+          </a:prstGeom>
+          <a:ln w="38100">
+            <a:solidFill>
+              <a:schemeClr val="tx1"/>
+            </a:solidFill>
+            <a:headEnd type="none" w="med" len="med"/>
+            <a:tailEnd type="triangle" w="med" len="med"/>
+          </a:ln>
+        </p:spPr>
+        <p:style>
+          <a:lnRef idx="1">
+            <a:schemeClr val="accent1"/>
+          </a:lnRef>
+          <a:fillRef idx="0">
+            <a:schemeClr val="accent1"/>
+          </a:fillRef>
+          <a:effectRef idx="0">
+            <a:schemeClr val="accent1"/>
+          </a:effectRef>
+          <a:fontRef idx="minor">
+            <a:schemeClr val="tx1"/>
+          </a:fontRef>
+        </p:style>
+      </p:cxnSp>
+      <p:sp>
+        <p:nvSpPr>
+          <p:cNvPr id="8" name="Oval 7">
+            <a:extLst>
+              <a:ext uri="{FF2B5EF4-FFF2-40B4-BE49-F238E27FC236}">
+                <a16:creationId xmlns:a16="http://schemas.microsoft.com/office/drawing/2014/main" id="{05856CF6-C4B5-97DA-4C5A-6DBFFCDD77E6}"/>
+              </a:ext>
+            </a:extLst>
+          </p:cNvPr>
+          <p:cNvSpPr/>
+          <p:nvPr/>
+        </p:nvSpPr>
+        <p:spPr>
+          <a:xfrm>
+            <a:off x="1612670" y="2938553"/>
+            <a:ext cx="266007" cy="224440"/>
+          </a:xfrm>
+          <a:prstGeom prst="ellipse">
+            <a:avLst/>
+          </a:prstGeom>
+        </p:spPr>
+        <p:style>
+          <a:lnRef idx="2">
+            <a:schemeClr val="accent1">
+              <a:shade val="15000"/>
+            </a:schemeClr>
+          </a:lnRef>
+          <a:fillRef idx="1">
+            <a:schemeClr val="accent1"/>
+          </a:fillRef>
+          <a:effectRef idx="0">
+            <a:schemeClr val="accent1"/>
+          </a:effectRef>
+          <a:fontRef idx="minor">
+            <a:schemeClr val="lt1"/>
+          </a:fontRef>
+        </p:style>
+        <p:txBody>
+          <a:bodyPr rtlCol="0" anchor="ctr"/>
+          <a:lstStyle/>
+          <a:p>
+            <a:pPr algn="ctr"/>
             <a:endParaRPr lang="en-US"/>
           </a:p>
         </p:txBody>
       </p:sp>
       <p:sp>
         <p:nvSpPr>
-          <p:cNvPr id="3" name="Content Placeholder 2">
-            <a:extLst>
-              <a:ext uri="{FF2B5EF4-FFF2-40B4-BE49-F238E27FC236}">
-                <a16:creationId xmlns:a16="http://schemas.microsoft.com/office/drawing/2014/main" id="{F1864206-33F4-FF6D-E91F-20DC1A48D332}"/>
-              </a:ext>
-            </a:extLst>
-          </p:cNvPr>
-          <p:cNvSpPr>
-            <a:spLocks noGrp="1"/>
-          </p:cNvSpPr>
-          <p:nvPr>
-            <p:ph idx="1"/>
-          </p:nvPr>
-        </p:nvSpPr>
-        <p:spPr/>
-        <p:txBody>
-          <a:bodyPr/>
-          <a:lstStyle/>
-          <a:p>
+          <p:cNvPr id="10" name="Oval 9">
+            <a:extLst>
+              <a:ext uri="{FF2B5EF4-FFF2-40B4-BE49-F238E27FC236}">
+                <a16:creationId xmlns:a16="http://schemas.microsoft.com/office/drawing/2014/main" id="{90A7F9F7-6A7A-F989-979C-1B0A81A6D63B}"/>
+              </a:ext>
+            </a:extLst>
+          </p:cNvPr>
+          <p:cNvSpPr/>
+          <p:nvPr/>
+        </p:nvSpPr>
+        <p:spPr>
+          <a:xfrm>
+            <a:off x="3460866" y="2938553"/>
+            <a:ext cx="266007" cy="224440"/>
+          </a:xfrm>
+          <a:prstGeom prst="ellipse">
+            <a:avLst/>
+          </a:prstGeom>
+        </p:spPr>
+        <p:style>
+          <a:lnRef idx="2">
+            <a:schemeClr val="accent1">
+              <a:shade val="15000"/>
+            </a:schemeClr>
+          </a:lnRef>
+          <a:fillRef idx="1">
+            <a:schemeClr val="accent1"/>
+          </a:fillRef>
+          <a:effectRef idx="0">
+            <a:schemeClr val="accent1"/>
+          </a:effectRef>
+          <a:fontRef idx="minor">
+            <a:schemeClr val="lt1"/>
+          </a:fontRef>
+        </p:style>
+        <p:txBody>
+          <a:bodyPr rtlCol="0" anchor="ctr"/>
+          <a:lstStyle/>
+          <a:p>
+            <a:pPr algn="ctr"/>
             <a:endParaRPr lang="en-US"/>
           </a:p>
         </p:txBody>
       </p:sp>
+      <p:sp>
+        <p:nvSpPr>
+          <p:cNvPr id="14" name="Oval 13">
+            <a:extLst>
+              <a:ext uri="{FF2B5EF4-FFF2-40B4-BE49-F238E27FC236}">
+                <a16:creationId xmlns:a16="http://schemas.microsoft.com/office/drawing/2014/main" id="{107DDE79-003A-A3D1-9F8D-153DCF2CE903}"/>
+              </a:ext>
+            </a:extLst>
+          </p:cNvPr>
+          <p:cNvSpPr/>
+          <p:nvPr/>
+        </p:nvSpPr>
+        <p:spPr>
+          <a:xfrm>
+            <a:off x="9504913" y="2938553"/>
+            <a:ext cx="266007" cy="224440"/>
+          </a:xfrm>
+          <a:prstGeom prst="ellipse">
+            <a:avLst/>
+          </a:prstGeom>
+        </p:spPr>
+        <p:style>
+          <a:lnRef idx="2">
+            <a:schemeClr val="accent1">
+              <a:shade val="15000"/>
+            </a:schemeClr>
+          </a:lnRef>
+          <a:fillRef idx="1">
+            <a:schemeClr val="accent1"/>
+          </a:fillRef>
+          <a:effectRef idx="0">
+            <a:schemeClr val="accent1"/>
+          </a:effectRef>
+          <a:fontRef idx="minor">
+            <a:schemeClr val="lt1"/>
+          </a:fontRef>
+        </p:style>
+        <p:txBody>
+          <a:bodyPr rtlCol="0" anchor="ctr"/>
+          <a:lstStyle/>
+          <a:p>
+            <a:pPr algn="ctr"/>
+            <a:endParaRPr lang="en-US"/>
+          </a:p>
+        </p:txBody>
+      </p:sp>
+      <p:sp>
+        <p:nvSpPr>
+          <p:cNvPr id="16" name="Oval 15">
+            <a:extLst>
+              <a:ext uri="{FF2B5EF4-FFF2-40B4-BE49-F238E27FC236}">
+                <a16:creationId xmlns:a16="http://schemas.microsoft.com/office/drawing/2014/main" id="{6D1B8D16-1479-09F8-8A12-BFBE3D694FBB}"/>
+              </a:ext>
+            </a:extLst>
+          </p:cNvPr>
+          <p:cNvSpPr/>
+          <p:nvPr/>
+        </p:nvSpPr>
+        <p:spPr>
+          <a:xfrm>
+            <a:off x="4206241" y="2938553"/>
+            <a:ext cx="266007" cy="224440"/>
+          </a:xfrm>
+          <a:prstGeom prst="ellipse">
+            <a:avLst/>
+          </a:prstGeom>
+        </p:spPr>
+        <p:style>
+          <a:lnRef idx="2">
+            <a:schemeClr val="accent1">
+              <a:shade val="15000"/>
+            </a:schemeClr>
+          </a:lnRef>
+          <a:fillRef idx="1">
+            <a:schemeClr val="accent1"/>
+          </a:fillRef>
+          <a:effectRef idx="0">
+            <a:schemeClr val="accent1"/>
+          </a:effectRef>
+          <a:fontRef idx="minor">
+            <a:schemeClr val="lt1"/>
+          </a:fontRef>
+        </p:style>
+        <p:txBody>
+          <a:bodyPr rtlCol="0" anchor="ctr"/>
+          <a:lstStyle/>
+          <a:p>
+            <a:pPr algn="ctr"/>
+            <a:endParaRPr lang="en-US"/>
+          </a:p>
+        </p:txBody>
+      </p:sp>
+      <p:sp>
+        <p:nvSpPr>
+          <p:cNvPr id="17" name="TextBox 16">
+            <a:extLst>
+              <a:ext uri="{FF2B5EF4-FFF2-40B4-BE49-F238E27FC236}">
+                <a16:creationId xmlns:a16="http://schemas.microsoft.com/office/drawing/2014/main" id="{3AADFBC4-6835-6A64-B75D-72C321229B8A}"/>
+              </a:ext>
+            </a:extLst>
+          </p:cNvPr>
+          <p:cNvSpPr txBox="1"/>
+          <p:nvPr/>
+        </p:nvSpPr>
+        <p:spPr>
+          <a:xfrm flipH="1">
+            <a:off x="10480272" y="2758384"/>
+            <a:ext cx="336666" cy="584775"/>
+          </a:xfrm>
+          <a:prstGeom prst="rect">
+            <a:avLst/>
+          </a:prstGeom>
+          <a:noFill/>
+        </p:spPr>
+        <p:txBody>
+          <a:bodyPr wrap="square" rtlCol="0">
+            <a:spAutoFit/>
+          </a:bodyPr>
+          <a:lstStyle/>
+          <a:p>
+            <a:r>
+              <a:rPr lang="en-US" sz="3200" b="1" dirty="0"/>
+              <a:t>X</a:t>
+            </a:r>
+          </a:p>
+        </p:txBody>
+      </p:sp>
+      <p:sp>
+        <p:nvSpPr>
+          <p:cNvPr id="18" name="Rectangle 17">
+            <a:extLst>
+              <a:ext uri="{FF2B5EF4-FFF2-40B4-BE49-F238E27FC236}">
+                <a16:creationId xmlns:a16="http://schemas.microsoft.com/office/drawing/2014/main" id="{23A99B68-44C3-F9B8-95AA-A8FD93CD27E1}"/>
+              </a:ext>
+            </a:extLst>
+          </p:cNvPr>
+          <p:cNvSpPr/>
+          <p:nvPr/>
+        </p:nvSpPr>
+        <p:spPr>
+          <a:xfrm>
+            <a:off x="1745673" y="195305"/>
+            <a:ext cx="914400" cy="457200"/>
+          </a:xfrm>
+          <a:prstGeom prst="rect">
+            <a:avLst/>
+          </a:prstGeom>
+          <a:solidFill>
+            <a:schemeClr val="accent1">
+              <a:alpha val="37000"/>
+            </a:schemeClr>
+          </a:solidFill>
+        </p:spPr>
+        <p:style>
+          <a:lnRef idx="2">
+            <a:schemeClr val="accent1">
+              <a:shade val="15000"/>
+            </a:schemeClr>
+          </a:lnRef>
+          <a:fillRef idx="1">
+            <a:schemeClr val="accent1"/>
+          </a:fillRef>
+          <a:effectRef idx="0">
+            <a:schemeClr val="accent1"/>
+          </a:effectRef>
+          <a:fontRef idx="minor">
+            <a:schemeClr val="lt1"/>
+          </a:fontRef>
+        </p:style>
+        <p:txBody>
+          <a:bodyPr rtlCol="0" anchor="ctr"/>
+          <a:lstStyle/>
+          <a:p>
+            <a:pPr algn="ctr"/>
+            <a:r>
+              <a:rPr lang="en-US" dirty="0"/>
+              <a:t>7</a:t>
+            </a:r>
+          </a:p>
+        </p:txBody>
+      </p:sp>
+      <p:sp>
+        <p:nvSpPr>
+          <p:cNvPr id="20" name="Rectangle 19">
+            <a:extLst>
+              <a:ext uri="{FF2B5EF4-FFF2-40B4-BE49-F238E27FC236}">
+                <a16:creationId xmlns:a16="http://schemas.microsoft.com/office/drawing/2014/main" id="{B1538338-9937-FCA2-BF1B-E669CF9819A3}"/>
+              </a:ext>
+            </a:extLst>
+          </p:cNvPr>
+          <p:cNvSpPr/>
+          <p:nvPr/>
+        </p:nvSpPr>
+        <p:spPr>
+          <a:xfrm>
+            <a:off x="1729048" y="1338329"/>
+            <a:ext cx="2743200" cy="457200"/>
+          </a:xfrm>
+          <a:prstGeom prst="rect">
+            <a:avLst/>
+          </a:prstGeom>
+          <a:solidFill>
+            <a:schemeClr val="accent1">
+              <a:alpha val="37000"/>
+            </a:schemeClr>
+          </a:solidFill>
+        </p:spPr>
+        <p:style>
+          <a:lnRef idx="2">
+            <a:schemeClr val="accent1">
+              <a:shade val="15000"/>
+            </a:schemeClr>
+          </a:lnRef>
+          <a:fillRef idx="1">
+            <a:schemeClr val="accent1"/>
+          </a:fillRef>
+          <a:effectRef idx="0">
+            <a:schemeClr val="accent1"/>
+          </a:effectRef>
+          <a:fontRef idx="minor">
+            <a:schemeClr val="lt1"/>
+          </a:fontRef>
+        </p:style>
+        <p:txBody>
+          <a:bodyPr rtlCol="0" anchor="ctr"/>
+          <a:lstStyle/>
+          <a:p>
+            <a:pPr algn="ctr"/>
+            <a:r>
+              <a:rPr lang="en-US" dirty="0"/>
+              <a:t>21</a:t>
+            </a:r>
+          </a:p>
+        </p:txBody>
+      </p:sp>
+      <p:sp>
+        <p:nvSpPr>
+          <p:cNvPr id="22" name="Rectangle 21">
+            <a:extLst>
+              <a:ext uri="{FF2B5EF4-FFF2-40B4-BE49-F238E27FC236}">
+                <a16:creationId xmlns:a16="http://schemas.microsoft.com/office/drawing/2014/main" id="{B1EF6C51-3F2B-574C-80DB-AC91106F18D4}"/>
+              </a:ext>
+            </a:extLst>
+          </p:cNvPr>
+          <p:cNvSpPr/>
+          <p:nvPr/>
+        </p:nvSpPr>
+        <p:spPr>
+          <a:xfrm>
+            <a:off x="1729048" y="734935"/>
+            <a:ext cx="1828800" cy="457200"/>
+          </a:xfrm>
+          <a:prstGeom prst="rect">
+            <a:avLst/>
+          </a:prstGeom>
+          <a:solidFill>
+            <a:schemeClr val="accent1">
+              <a:alpha val="37000"/>
+            </a:schemeClr>
+          </a:solidFill>
+        </p:spPr>
+        <p:style>
+          <a:lnRef idx="2">
+            <a:schemeClr val="accent1">
+              <a:shade val="15000"/>
+            </a:schemeClr>
+          </a:lnRef>
+          <a:fillRef idx="1">
+            <a:schemeClr val="accent1"/>
+          </a:fillRef>
+          <a:effectRef idx="0">
+            <a:schemeClr val="accent1"/>
+          </a:effectRef>
+          <a:fontRef idx="minor">
+            <a:schemeClr val="lt1"/>
+          </a:fontRef>
+        </p:style>
+        <p:txBody>
+          <a:bodyPr rtlCol="0" anchor="ctr"/>
+          <a:lstStyle/>
+          <a:p>
+            <a:pPr algn="ctr"/>
+            <a:r>
+              <a:rPr lang="en-US" dirty="0"/>
+              <a:t>14</a:t>
+            </a:r>
+          </a:p>
+        </p:txBody>
+      </p:sp>
+    </p:spTree>
+    <p:extLst>
+      <p:ext uri="{BB962C8B-B14F-4D97-AF65-F5344CB8AC3E}">
+        <p14:creationId xmlns:p14="http://schemas.microsoft.com/office/powerpoint/2010/main" val="1646292237"/>
+      </p:ext>
+    </p:extLst>
+  </p:cSld>
+  <p:clrMapOvr>
+    <a:masterClrMapping/>
+  </p:clrMapOvr>
+  <p:timing>
+    <p:tnLst>
+      <p:par>
+        <p:cTn id="1" dur="indefinite" restart="never" nodeType="tmRoot">
+          <p:childTnLst>
+            <p:seq concurrent="1" nextAc="seek">
+              <p:cTn id="2" dur="indefinite" nodeType="mainSeq">
+                <p:childTnLst>
+                  <p:par>
+                    <p:cTn id="3" fill="hold">
+                      <p:stCondLst>
+                        <p:cond delay="indefinite"/>
+                      </p:stCondLst>
+                      <p:childTnLst>
+                        <p:par>
+                          <p:cTn id="4" fill="hold">
+                            <p:stCondLst>
+                              <p:cond delay="0"/>
+                            </p:stCondLst>
+                            <p:childTnLst>
+                              <p:par>
+                                <p:cTn id="5" presetID="1" presetClass="entr" presetSubtype="0" fill="hold" grpId="0" nodeType="clickEffect">
+                                  <p:stCondLst>
+                                    <p:cond delay="0"/>
+                                  </p:stCondLst>
+                                  <p:childTnLst>
+                                    <p:set>
+                                      <p:cBhvr>
+                                        <p:cTn id="6" dur="1" fill="hold">
+                                          <p:stCondLst>
+                                            <p:cond delay="0"/>
+                                          </p:stCondLst>
+                                        </p:cTn>
+                                        <p:tgtEl>
+                                          <p:spTgt spid="10"/>
+                                        </p:tgtEl>
+                                        <p:attrNameLst>
+                                          <p:attrName>style.visibility</p:attrName>
+                                        </p:attrNameLst>
+                                      </p:cBhvr>
+                                      <p:to>
+                                        <p:strVal val="visible"/>
+                                      </p:to>
+                                    </p:set>
+                                  </p:childTnLst>
+                                </p:cTn>
+                              </p:par>
+                            </p:childTnLst>
+                          </p:cTn>
+                        </p:par>
+                      </p:childTnLst>
+                    </p:cTn>
+                  </p:par>
+                  <p:par>
+                    <p:cTn id="7" fill="hold">
+                      <p:stCondLst>
+                        <p:cond delay="indefinite"/>
+                      </p:stCondLst>
+                      <p:childTnLst>
+                        <p:par>
+                          <p:cTn id="8" fill="hold">
+                            <p:stCondLst>
+                              <p:cond delay="0"/>
+                            </p:stCondLst>
+                            <p:childTnLst>
+                              <p:par>
+                                <p:cTn id="9" presetID="1" presetClass="entr" presetSubtype="0" fill="hold" grpId="0" nodeType="clickEffect">
+                                  <p:stCondLst>
+                                    <p:cond delay="0"/>
+                                  </p:stCondLst>
+                                  <p:childTnLst>
+                                    <p:set>
+                                      <p:cBhvr>
+                                        <p:cTn id="10" dur="1" fill="hold">
+                                          <p:stCondLst>
+                                            <p:cond delay="0"/>
+                                          </p:stCondLst>
+                                        </p:cTn>
+                                        <p:tgtEl>
+                                          <p:spTgt spid="16"/>
+                                        </p:tgtEl>
+                                        <p:attrNameLst>
+                                          <p:attrName>style.visibility</p:attrName>
+                                        </p:attrNameLst>
+                                      </p:cBhvr>
+                                      <p:to>
+                                        <p:strVal val="visible"/>
+                                      </p:to>
+                                    </p:set>
+                                  </p:childTnLst>
+                                </p:cTn>
+                              </p:par>
+                            </p:childTnLst>
+                          </p:cTn>
+                        </p:par>
+                      </p:childTnLst>
+                    </p:cTn>
+                  </p:par>
+                  <p:par>
+                    <p:cTn id="11" fill="hold">
+                      <p:stCondLst>
+                        <p:cond delay="indefinite"/>
+                      </p:stCondLst>
+                      <p:childTnLst>
+                        <p:par>
+                          <p:cTn id="12" fill="hold">
+                            <p:stCondLst>
+                              <p:cond delay="0"/>
+                            </p:stCondLst>
+                            <p:childTnLst>
+                              <p:par>
+                                <p:cTn id="13" presetID="1" presetClass="entr" presetSubtype="0" fill="hold" grpId="0" nodeType="clickEffect">
+                                  <p:stCondLst>
+                                    <p:cond delay="0"/>
+                                  </p:stCondLst>
+                                  <p:childTnLst>
+                                    <p:set>
+                                      <p:cBhvr>
+                                        <p:cTn id="14" dur="1" fill="hold">
+                                          <p:stCondLst>
+                                            <p:cond delay="0"/>
+                                          </p:stCondLst>
+                                        </p:cTn>
+                                        <p:tgtEl>
+                                          <p:spTgt spid="14"/>
+                                        </p:tgtEl>
+                                        <p:attrNameLst>
+                                          <p:attrName>style.visibility</p:attrName>
+                                        </p:attrNameLst>
+                                      </p:cBhvr>
+                                      <p:to>
+                                        <p:strVal val="visible"/>
+                                      </p:to>
+                                    </p:set>
+                                  </p:childTnLst>
+                                </p:cTn>
+                              </p:par>
+                            </p:childTnLst>
+                          </p:cTn>
+                        </p:par>
+                      </p:childTnLst>
+                    </p:cTn>
+                  </p:par>
+                  <p:par>
+                    <p:cTn id="15" fill="hold">
+                      <p:stCondLst>
+                        <p:cond delay="indefinite"/>
+                      </p:stCondLst>
+                      <p:childTnLst>
+                        <p:par>
+                          <p:cTn id="16" fill="hold">
+                            <p:stCondLst>
+                              <p:cond delay="0"/>
+                            </p:stCondLst>
+                            <p:childTnLst>
+                              <p:par>
+                                <p:cTn id="17" presetID="1" presetClass="entr" presetSubtype="0" fill="hold" grpId="0" nodeType="clickEffect">
+                                  <p:stCondLst>
+                                    <p:cond delay="0"/>
+                                  </p:stCondLst>
+                                  <p:childTnLst>
+                                    <p:set>
+                                      <p:cBhvr>
+                                        <p:cTn id="18" dur="1" fill="hold">
+                                          <p:stCondLst>
+                                            <p:cond delay="0"/>
+                                          </p:stCondLst>
+                                        </p:cTn>
+                                        <p:tgtEl>
+                                          <p:spTgt spid="17"/>
+                                        </p:tgtEl>
+                                        <p:attrNameLst>
+                                          <p:attrName>style.visibility</p:attrName>
+                                        </p:attrNameLst>
+                                      </p:cBhvr>
+                                      <p:to>
+                                        <p:strVal val="visible"/>
+                                      </p:to>
+                                    </p:set>
+                                  </p:childTnLst>
+                                </p:cTn>
+                              </p:par>
+                            </p:childTnLst>
+                          </p:cTn>
+                        </p:par>
+                      </p:childTnLst>
+                    </p:cTn>
+                  </p:par>
+                  <p:par>
+                    <p:cTn id="19" fill="hold">
+                      <p:stCondLst>
+                        <p:cond delay="indefinite"/>
+                      </p:stCondLst>
+                      <p:childTnLst>
+                        <p:par>
+                          <p:cTn id="20" fill="hold">
+                            <p:stCondLst>
+                              <p:cond delay="0"/>
+                            </p:stCondLst>
+                            <p:childTnLst>
+                              <p:par>
+                                <p:cTn id="21" presetID="1" presetClass="entr" presetSubtype="0" fill="hold" grpId="0" nodeType="clickEffect">
+                                  <p:stCondLst>
+                                    <p:cond delay="0"/>
+                                  </p:stCondLst>
+                                  <p:childTnLst>
+                                    <p:set>
+                                      <p:cBhvr>
+                                        <p:cTn id="22" dur="1" fill="hold">
+                                          <p:stCondLst>
+                                            <p:cond delay="0"/>
+                                          </p:stCondLst>
+                                        </p:cTn>
+                                        <p:tgtEl>
+                                          <p:spTgt spid="18"/>
+                                        </p:tgtEl>
+                                        <p:attrNameLst>
+                                          <p:attrName>style.visibility</p:attrName>
+                                        </p:attrNameLst>
+                                      </p:cBhvr>
+                                      <p:to>
+                                        <p:strVal val="visible"/>
+                                      </p:to>
+                                    </p:set>
+                                  </p:childTnLst>
+                                </p:cTn>
+                              </p:par>
+                              <p:par>
+                                <p:cTn id="23" presetID="1" presetClass="entr" presetSubtype="0" fill="hold" grpId="0" nodeType="withEffect">
+                                  <p:stCondLst>
+                                    <p:cond delay="0"/>
+                                  </p:stCondLst>
+                                  <p:childTnLst>
+                                    <p:set>
+                                      <p:cBhvr>
+                                        <p:cTn id="24" dur="1" fill="hold">
+                                          <p:stCondLst>
+                                            <p:cond delay="0"/>
+                                          </p:stCondLst>
+                                        </p:cTn>
+                                        <p:tgtEl>
+                                          <p:spTgt spid="20"/>
+                                        </p:tgtEl>
+                                        <p:attrNameLst>
+                                          <p:attrName>style.visibility</p:attrName>
+                                        </p:attrNameLst>
+                                      </p:cBhvr>
+                                      <p:to>
+                                        <p:strVal val="visible"/>
+                                      </p:to>
+                                    </p:set>
+                                  </p:childTnLst>
+                                </p:cTn>
+                              </p:par>
+                              <p:par>
+                                <p:cTn id="25" presetID="1" presetClass="entr" presetSubtype="0" fill="hold" grpId="0" nodeType="withEffect">
+                                  <p:stCondLst>
+                                    <p:cond delay="0"/>
+                                  </p:stCondLst>
+                                  <p:childTnLst>
+                                    <p:set>
+                                      <p:cBhvr>
+                                        <p:cTn id="26" dur="1" fill="hold">
+                                          <p:stCondLst>
+                                            <p:cond delay="0"/>
+                                          </p:stCondLst>
+                                        </p:cTn>
+                                        <p:tgtEl>
+                                          <p:spTgt spid="22"/>
+                                        </p:tgtEl>
+                                        <p:attrNameLst>
+                                          <p:attrName>style.visibility</p:attrName>
+                                        </p:attrNameLst>
+                                      </p:cBhvr>
+                                      <p:to>
+                                        <p:strVal val="visible"/>
+                                      </p:to>
+                                    </p:set>
+                                  </p:childTnLst>
+                                </p:cTn>
+                              </p:par>
+                            </p:childTnLst>
+                          </p:cTn>
+                        </p:par>
+                      </p:childTnLst>
+                    </p:cTn>
+                  </p:par>
+                </p:childTnLst>
+              </p:cTn>
+              <p:prevCondLst>
+                <p:cond evt="onPrev" delay="0">
+                  <p:tgtEl>
+                    <p:sldTgt/>
+                  </p:tgtEl>
+                </p:cond>
+              </p:prevCondLst>
+              <p:nextCondLst>
+                <p:cond evt="onNext" delay="0">
+                  <p:tgtEl>
+                    <p:sldTgt/>
+                  </p:tgtEl>
+                </p:cond>
+              </p:nextCondLst>
+            </p:seq>
+          </p:childTnLst>
+        </p:cTn>
+      </p:par>
+    </p:tnLst>
+    <p:bldLst>
+      <p:bldP spid="10" grpId="0" animBg="1"/>
+      <p:bldP spid="14" grpId="0" animBg="1"/>
+      <p:bldP spid="16" grpId="0" animBg="1"/>
+      <p:bldP spid="17" grpId="0"/>
+      <p:bldP spid="18" grpId="0" animBg="1"/>
+      <p:bldP spid="20" grpId="0" animBg="1"/>
+      <p:bldP spid="22" grpId="0" animBg="1"/>
+    </p:bldLst>
+  </p:timing>
+</p:sld>
+</file>
+
+<file path=ppt/slides/slide3.xml><?xml version="1.0" encoding="utf-8"?>
+<p:sld xmlns:a="http://schemas.openxmlformats.org/drawingml/2006/main" xmlns:r="http://schemas.openxmlformats.org/officeDocument/2006/relationships" xmlns:p="http://schemas.openxmlformats.org/presentationml/2006/main">
+  <p:cSld>
+    <p:spTree>
+      <p:nvGrpSpPr>
+        <p:cNvPr id="1" name="">
+          <a:extLst>
+            <a:ext uri="{FF2B5EF4-FFF2-40B4-BE49-F238E27FC236}">
+              <a16:creationId xmlns:a16="http://schemas.microsoft.com/office/drawing/2014/main" id="{D0CCEE19-3CB8-0ACF-9FE1-73F3E558CB13}"/>
+            </a:ext>
+          </a:extLst>
+        </p:cNvPr>
+        <p:cNvGrpSpPr/>
+        <p:nvPr/>
+      </p:nvGrpSpPr>
+      <p:grpSpPr>
+        <a:xfrm>
+          <a:off x="0" y="0"/>
+          <a:ext cx="0" cy="0"/>
+          <a:chOff x="0" y="0"/>
+          <a:chExt cx="0" cy="0"/>
+        </a:xfrm>
+      </p:grpSpPr>
+      <p:cxnSp>
+        <p:nvCxnSpPr>
+          <p:cNvPr id="7" name="Straight Connector 6">
+            <a:extLst>
+              <a:ext uri="{FF2B5EF4-FFF2-40B4-BE49-F238E27FC236}">
+                <a16:creationId xmlns:a16="http://schemas.microsoft.com/office/drawing/2014/main" id="{ADCD1E1E-3DB9-3347-B35C-6FD68D52CB0D}"/>
+              </a:ext>
+            </a:extLst>
+          </p:cNvPr>
+          <p:cNvCxnSpPr/>
+          <p:nvPr/>
+        </p:nvCxnSpPr>
+        <p:spPr>
+          <a:xfrm>
+            <a:off x="1745674" y="3050773"/>
+            <a:ext cx="8902931" cy="0"/>
+          </a:xfrm>
+          <a:prstGeom prst="line">
+            <a:avLst/>
+          </a:prstGeom>
+          <a:ln w="38100">
+            <a:solidFill>
+              <a:schemeClr val="tx1"/>
+            </a:solidFill>
+            <a:headEnd type="none" w="med" len="med"/>
+            <a:tailEnd type="triangle" w="med" len="med"/>
+          </a:ln>
+        </p:spPr>
+        <p:style>
+          <a:lnRef idx="1">
+            <a:schemeClr val="accent1"/>
+          </a:lnRef>
+          <a:fillRef idx="0">
+            <a:schemeClr val="accent1"/>
+          </a:fillRef>
+          <a:effectRef idx="0">
+            <a:schemeClr val="accent1"/>
+          </a:effectRef>
+          <a:fontRef idx="minor">
+            <a:schemeClr val="tx1"/>
+          </a:fontRef>
+        </p:style>
+      </p:cxnSp>
+      <p:sp>
+        <p:nvSpPr>
+          <p:cNvPr id="8" name="Oval 7">
+            <a:extLst>
+              <a:ext uri="{FF2B5EF4-FFF2-40B4-BE49-F238E27FC236}">
+                <a16:creationId xmlns:a16="http://schemas.microsoft.com/office/drawing/2014/main" id="{64CF4C1F-83B1-1175-9244-4036A8CF408E}"/>
+              </a:ext>
+            </a:extLst>
+          </p:cNvPr>
+          <p:cNvSpPr/>
+          <p:nvPr/>
+        </p:nvSpPr>
+        <p:spPr>
+          <a:xfrm>
+            <a:off x="1612670" y="2938553"/>
+            <a:ext cx="266007" cy="224440"/>
+          </a:xfrm>
+          <a:prstGeom prst="ellipse">
+            <a:avLst/>
+          </a:prstGeom>
+        </p:spPr>
+        <p:style>
+          <a:lnRef idx="2">
+            <a:schemeClr val="accent1">
+              <a:shade val="15000"/>
+            </a:schemeClr>
+          </a:lnRef>
+          <a:fillRef idx="1">
+            <a:schemeClr val="accent1"/>
+          </a:fillRef>
+          <a:effectRef idx="0">
+            <a:schemeClr val="accent1"/>
+          </a:effectRef>
+          <a:fontRef idx="minor">
+            <a:schemeClr val="lt1"/>
+          </a:fontRef>
+        </p:style>
+        <p:txBody>
+          <a:bodyPr rtlCol="0" anchor="ctr"/>
+          <a:lstStyle/>
+          <a:p>
+            <a:pPr algn="ctr"/>
+            <a:endParaRPr lang="en-US"/>
+          </a:p>
+        </p:txBody>
+      </p:sp>
+      <p:sp>
+        <p:nvSpPr>
+          <p:cNvPr id="10" name="Oval 9">
+            <a:extLst>
+              <a:ext uri="{FF2B5EF4-FFF2-40B4-BE49-F238E27FC236}">
+                <a16:creationId xmlns:a16="http://schemas.microsoft.com/office/drawing/2014/main" id="{854DE37F-6762-D521-15F6-01AE0E5F8D48}"/>
+              </a:ext>
+            </a:extLst>
+          </p:cNvPr>
+          <p:cNvSpPr/>
+          <p:nvPr/>
+        </p:nvSpPr>
+        <p:spPr>
+          <a:xfrm>
+            <a:off x="3460866" y="2938553"/>
+            <a:ext cx="266007" cy="224440"/>
+          </a:xfrm>
+          <a:prstGeom prst="ellipse">
+            <a:avLst/>
+          </a:prstGeom>
+        </p:spPr>
+        <p:style>
+          <a:lnRef idx="2">
+            <a:schemeClr val="accent1">
+              <a:shade val="15000"/>
+            </a:schemeClr>
+          </a:lnRef>
+          <a:fillRef idx="1">
+            <a:schemeClr val="accent1"/>
+          </a:fillRef>
+          <a:effectRef idx="0">
+            <a:schemeClr val="accent1"/>
+          </a:effectRef>
+          <a:fontRef idx="minor">
+            <a:schemeClr val="lt1"/>
+          </a:fontRef>
+        </p:style>
+        <p:txBody>
+          <a:bodyPr rtlCol="0" anchor="ctr"/>
+          <a:lstStyle/>
+          <a:p>
+            <a:pPr algn="ctr"/>
+            <a:endParaRPr lang="en-US"/>
+          </a:p>
+        </p:txBody>
+      </p:sp>
+      <p:sp>
+        <p:nvSpPr>
+          <p:cNvPr id="14" name="Oval 13">
+            <a:extLst>
+              <a:ext uri="{FF2B5EF4-FFF2-40B4-BE49-F238E27FC236}">
+                <a16:creationId xmlns:a16="http://schemas.microsoft.com/office/drawing/2014/main" id="{D613C6C7-1720-8E16-B9D5-A350542FF886}"/>
+              </a:ext>
+            </a:extLst>
+          </p:cNvPr>
+          <p:cNvSpPr/>
+          <p:nvPr/>
+        </p:nvSpPr>
+        <p:spPr>
+          <a:xfrm>
+            <a:off x="9504913" y="2938553"/>
+            <a:ext cx="266007" cy="224440"/>
+          </a:xfrm>
+          <a:prstGeom prst="ellipse">
+            <a:avLst/>
+          </a:prstGeom>
+        </p:spPr>
+        <p:style>
+          <a:lnRef idx="2">
+            <a:schemeClr val="accent1">
+              <a:shade val="15000"/>
+            </a:schemeClr>
+          </a:lnRef>
+          <a:fillRef idx="1">
+            <a:schemeClr val="accent1"/>
+          </a:fillRef>
+          <a:effectRef idx="0">
+            <a:schemeClr val="accent1"/>
+          </a:effectRef>
+          <a:fontRef idx="minor">
+            <a:schemeClr val="lt1"/>
+          </a:fontRef>
+        </p:style>
+        <p:txBody>
+          <a:bodyPr rtlCol="0" anchor="ctr"/>
+          <a:lstStyle/>
+          <a:p>
+            <a:pPr algn="ctr"/>
+            <a:endParaRPr lang="en-US"/>
+          </a:p>
+        </p:txBody>
+      </p:sp>
+      <p:sp>
+        <p:nvSpPr>
+          <p:cNvPr id="16" name="Oval 15">
+            <a:extLst>
+              <a:ext uri="{FF2B5EF4-FFF2-40B4-BE49-F238E27FC236}">
+                <a16:creationId xmlns:a16="http://schemas.microsoft.com/office/drawing/2014/main" id="{20E45314-E9BD-E7A4-03D9-9FBCF6812B6D}"/>
+              </a:ext>
+            </a:extLst>
+          </p:cNvPr>
+          <p:cNvSpPr/>
+          <p:nvPr/>
+        </p:nvSpPr>
+        <p:spPr>
+          <a:xfrm>
+            <a:off x="4206241" y="2938553"/>
+            <a:ext cx="266007" cy="224440"/>
+          </a:xfrm>
+          <a:prstGeom prst="ellipse">
+            <a:avLst/>
+          </a:prstGeom>
+        </p:spPr>
+        <p:style>
+          <a:lnRef idx="2">
+            <a:schemeClr val="accent1">
+              <a:shade val="15000"/>
+            </a:schemeClr>
+          </a:lnRef>
+          <a:fillRef idx="1">
+            <a:schemeClr val="accent1"/>
+          </a:fillRef>
+          <a:effectRef idx="0">
+            <a:schemeClr val="accent1"/>
+          </a:effectRef>
+          <a:fontRef idx="minor">
+            <a:schemeClr val="lt1"/>
+          </a:fontRef>
+        </p:style>
+        <p:txBody>
+          <a:bodyPr rtlCol="0" anchor="ctr"/>
+          <a:lstStyle/>
+          <a:p>
+            <a:pPr algn="ctr"/>
+            <a:endParaRPr lang="en-US"/>
+          </a:p>
+        </p:txBody>
+      </p:sp>
+      <p:sp>
+        <p:nvSpPr>
+          <p:cNvPr id="17" name="TextBox 16">
+            <a:extLst>
+              <a:ext uri="{FF2B5EF4-FFF2-40B4-BE49-F238E27FC236}">
+                <a16:creationId xmlns:a16="http://schemas.microsoft.com/office/drawing/2014/main" id="{EEE67364-7455-6D90-C51C-1CED7368932D}"/>
+              </a:ext>
+            </a:extLst>
+          </p:cNvPr>
+          <p:cNvSpPr txBox="1"/>
+          <p:nvPr/>
+        </p:nvSpPr>
+        <p:spPr>
+          <a:xfrm flipH="1">
+            <a:off x="10480272" y="2758384"/>
+            <a:ext cx="336666" cy="584775"/>
+          </a:xfrm>
+          <a:prstGeom prst="rect">
+            <a:avLst/>
+          </a:prstGeom>
+          <a:noFill/>
+        </p:spPr>
+        <p:txBody>
+          <a:bodyPr wrap="square" rtlCol="0">
+            <a:spAutoFit/>
+          </a:bodyPr>
+          <a:lstStyle/>
+          <a:p>
+            <a:r>
+              <a:rPr lang="en-US" sz="3200" b="1" dirty="0"/>
+              <a:t>X</a:t>
+            </a:r>
+          </a:p>
+        </p:txBody>
+      </p:sp>
+      <p:sp>
+        <p:nvSpPr>
+          <p:cNvPr id="18" name="Rectangle 17">
+            <a:extLst>
+              <a:ext uri="{FF2B5EF4-FFF2-40B4-BE49-F238E27FC236}">
+                <a16:creationId xmlns:a16="http://schemas.microsoft.com/office/drawing/2014/main" id="{4FBAC3A0-A0E7-EDC1-689C-D3D6A982A395}"/>
+              </a:ext>
+            </a:extLst>
+          </p:cNvPr>
+          <p:cNvSpPr/>
+          <p:nvPr/>
+        </p:nvSpPr>
+        <p:spPr>
+          <a:xfrm>
+            <a:off x="1612670" y="2822171"/>
+            <a:ext cx="914400" cy="457200"/>
+          </a:xfrm>
+          <a:prstGeom prst="rect">
+            <a:avLst/>
+          </a:prstGeom>
+          <a:solidFill>
+            <a:schemeClr val="accent1">
+              <a:alpha val="37000"/>
+            </a:schemeClr>
+          </a:solidFill>
+        </p:spPr>
+        <p:style>
+          <a:lnRef idx="2">
+            <a:schemeClr val="accent1">
+              <a:shade val="15000"/>
+            </a:schemeClr>
+          </a:lnRef>
+          <a:fillRef idx="1">
+            <a:schemeClr val="accent1"/>
+          </a:fillRef>
+          <a:effectRef idx="0">
+            <a:schemeClr val="accent1"/>
+          </a:effectRef>
+          <a:fontRef idx="minor">
+            <a:schemeClr val="lt1"/>
+          </a:fontRef>
+        </p:style>
+        <p:txBody>
+          <a:bodyPr rtlCol="0" anchor="ctr"/>
+          <a:lstStyle/>
+          <a:p>
+            <a:pPr algn="ctr"/>
+            <a:r>
+              <a:rPr lang="en-US" dirty="0"/>
+              <a:t>7</a:t>
+            </a:r>
+          </a:p>
+        </p:txBody>
+      </p:sp>
+      <p:sp>
+        <p:nvSpPr>
+          <p:cNvPr id="3" name="Rectangle 2">
+            <a:extLst>
+              <a:ext uri="{FF2B5EF4-FFF2-40B4-BE49-F238E27FC236}">
+                <a16:creationId xmlns:a16="http://schemas.microsoft.com/office/drawing/2014/main" id="{B07D35A5-9395-2047-812F-4BF8783C6B28}"/>
+              </a:ext>
+            </a:extLst>
+          </p:cNvPr>
+          <p:cNvSpPr/>
+          <p:nvPr/>
+        </p:nvSpPr>
+        <p:spPr>
+          <a:xfrm>
+            <a:off x="3460866" y="2822171"/>
+            <a:ext cx="914400" cy="457200"/>
+          </a:xfrm>
+          <a:prstGeom prst="rect">
+            <a:avLst/>
+          </a:prstGeom>
+          <a:solidFill>
+            <a:schemeClr val="accent1">
+              <a:alpha val="37000"/>
+            </a:schemeClr>
+          </a:solidFill>
+        </p:spPr>
+        <p:style>
+          <a:lnRef idx="2">
+            <a:schemeClr val="accent1">
+              <a:shade val="15000"/>
+            </a:schemeClr>
+          </a:lnRef>
+          <a:fillRef idx="1">
+            <a:schemeClr val="accent1"/>
+          </a:fillRef>
+          <a:effectRef idx="0">
+            <a:schemeClr val="accent1"/>
+          </a:effectRef>
+          <a:fontRef idx="minor">
+            <a:schemeClr val="lt1"/>
+          </a:fontRef>
+        </p:style>
+        <p:txBody>
+          <a:bodyPr rtlCol="0" anchor="ctr"/>
+          <a:lstStyle/>
+          <a:p>
+            <a:pPr algn="ctr"/>
+            <a:r>
+              <a:rPr lang="en-US" dirty="0"/>
+              <a:t>7</a:t>
+            </a:r>
+          </a:p>
+        </p:txBody>
+      </p:sp>
+      <p:sp>
+        <p:nvSpPr>
+          <p:cNvPr id="5" name="Rectangle 4">
+            <a:extLst>
+              <a:ext uri="{FF2B5EF4-FFF2-40B4-BE49-F238E27FC236}">
+                <a16:creationId xmlns:a16="http://schemas.microsoft.com/office/drawing/2014/main" id="{D33749C6-7642-0F8C-ECAB-DF192096BE2D}"/>
+              </a:ext>
+            </a:extLst>
+          </p:cNvPr>
+          <p:cNvSpPr/>
+          <p:nvPr/>
+        </p:nvSpPr>
+        <p:spPr>
+          <a:xfrm>
+            <a:off x="4378474" y="2822171"/>
+            <a:ext cx="914400" cy="457200"/>
+          </a:xfrm>
+          <a:prstGeom prst="rect">
+            <a:avLst/>
+          </a:prstGeom>
+          <a:solidFill>
+            <a:schemeClr val="accent1">
+              <a:alpha val="37000"/>
+            </a:schemeClr>
+          </a:solidFill>
+        </p:spPr>
+        <p:style>
+          <a:lnRef idx="2">
+            <a:schemeClr val="accent1">
+              <a:shade val="15000"/>
+            </a:schemeClr>
+          </a:lnRef>
+          <a:fillRef idx="1">
+            <a:schemeClr val="accent1"/>
+          </a:fillRef>
+          <a:effectRef idx="0">
+            <a:schemeClr val="accent1"/>
+          </a:effectRef>
+          <a:fontRef idx="minor">
+            <a:schemeClr val="lt1"/>
+          </a:fontRef>
+        </p:style>
+        <p:txBody>
+          <a:bodyPr rtlCol="0" anchor="ctr"/>
+          <a:lstStyle/>
+          <a:p>
+            <a:pPr algn="ctr"/>
+            <a:r>
+              <a:rPr lang="en-US" dirty="0"/>
+              <a:t>7</a:t>
+            </a:r>
+          </a:p>
+        </p:txBody>
+      </p:sp>
+      <p:sp>
+        <p:nvSpPr>
+          <p:cNvPr id="9" name="Rectangle 8">
+            <a:extLst>
+              <a:ext uri="{FF2B5EF4-FFF2-40B4-BE49-F238E27FC236}">
+                <a16:creationId xmlns:a16="http://schemas.microsoft.com/office/drawing/2014/main" id="{32639A70-B714-C0F3-C892-6D951E489661}"/>
+              </a:ext>
+            </a:extLst>
+          </p:cNvPr>
+          <p:cNvSpPr/>
+          <p:nvPr/>
+        </p:nvSpPr>
+        <p:spPr>
+          <a:xfrm>
+            <a:off x="9529505" y="2822171"/>
+            <a:ext cx="914400" cy="457200"/>
+          </a:xfrm>
+          <a:prstGeom prst="rect">
+            <a:avLst/>
+          </a:prstGeom>
+          <a:solidFill>
+            <a:schemeClr val="accent1">
+              <a:alpha val="37000"/>
+            </a:schemeClr>
+          </a:solidFill>
+        </p:spPr>
+        <p:style>
+          <a:lnRef idx="2">
+            <a:schemeClr val="accent1">
+              <a:shade val="15000"/>
+            </a:schemeClr>
+          </a:lnRef>
+          <a:fillRef idx="1">
+            <a:schemeClr val="accent1"/>
+          </a:fillRef>
+          <a:effectRef idx="0">
+            <a:schemeClr val="accent1"/>
+          </a:effectRef>
+          <a:fontRef idx="minor">
+            <a:schemeClr val="lt1"/>
+          </a:fontRef>
+        </p:style>
+        <p:txBody>
+          <a:bodyPr rtlCol="0" anchor="ctr"/>
+          <a:lstStyle/>
+          <a:p>
+            <a:pPr algn="ctr"/>
+            <a:r>
+              <a:rPr lang="en-US" dirty="0"/>
+              <a:t>7</a:t>
+            </a:r>
+          </a:p>
+        </p:txBody>
+      </p:sp>
+      <p:cxnSp>
+        <p:nvCxnSpPr>
+          <p:cNvPr id="11" name="Straight Connector 10">
+            <a:extLst>
+              <a:ext uri="{FF2B5EF4-FFF2-40B4-BE49-F238E27FC236}">
+                <a16:creationId xmlns:a16="http://schemas.microsoft.com/office/drawing/2014/main" id="{D2208358-ED3C-BD53-3A5D-9E03EC027CCC}"/>
+              </a:ext>
+            </a:extLst>
+          </p:cNvPr>
+          <p:cNvCxnSpPr/>
+          <p:nvPr/>
+        </p:nvCxnSpPr>
+        <p:spPr>
+          <a:xfrm>
+            <a:off x="1745674" y="4154524"/>
+            <a:ext cx="8902931" cy="0"/>
+          </a:xfrm>
+          <a:prstGeom prst="line">
+            <a:avLst/>
+          </a:prstGeom>
+          <a:ln w="38100">
+            <a:solidFill>
+              <a:schemeClr val="tx1"/>
+            </a:solidFill>
+            <a:headEnd type="none" w="med" len="med"/>
+            <a:tailEnd type="triangle" w="med" len="med"/>
+          </a:ln>
+        </p:spPr>
+        <p:style>
+          <a:lnRef idx="1">
+            <a:schemeClr val="accent1"/>
+          </a:lnRef>
+          <a:fillRef idx="0">
+            <a:schemeClr val="accent1"/>
+          </a:fillRef>
+          <a:effectRef idx="0">
+            <a:schemeClr val="accent1"/>
+          </a:effectRef>
+          <a:fontRef idx="minor">
+            <a:schemeClr val="tx1"/>
+          </a:fontRef>
+        </p:style>
+      </p:cxnSp>
+      <p:sp>
+        <p:nvSpPr>
+          <p:cNvPr id="12" name="Oval 11">
+            <a:extLst>
+              <a:ext uri="{FF2B5EF4-FFF2-40B4-BE49-F238E27FC236}">
+                <a16:creationId xmlns:a16="http://schemas.microsoft.com/office/drawing/2014/main" id="{BB1F5150-0F16-4C2B-1CB6-C7E1B770568A}"/>
+              </a:ext>
+            </a:extLst>
+          </p:cNvPr>
+          <p:cNvSpPr/>
+          <p:nvPr/>
+        </p:nvSpPr>
+        <p:spPr>
+          <a:xfrm>
+            <a:off x="1612670" y="4042304"/>
+            <a:ext cx="266007" cy="224440"/>
+          </a:xfrm>
+          <a:prstGeom prst="ellipse">
+            <a:avLst/>
+          </a:prstGeom>
+        </p:spPr>
+        <p:style>
+          <a:lnRef idx="2">
+            <a:schemeClr val="accent1">
+              <a:shade val="15000"/>
+            </a:schemeClr>
+          </a:lnRef>
+          <a:fillRef idx="1">
+            <a:schemeClr val="accent1"/>
+          </a:fillRef>
+          <a:effectRef idx="0">
+            <a:schemeClr val="accent1"/>
+          </a:effectRef>
+          <a:fontRef idx="minor">
+            <a:schemeClr val="lt1"/>
+          </a:fontRef>
+        </p:style>
+        <p:txBody>
+          <a:bodyPr rtlCol="0" anchor="ctr"/>
+          <a:lstStyle/>
+          <a:p>
+            <a:pPr algn="ctr"/>
+            <a:endParaRPr lang="en-US"/>
+          </a:p>
+        </p:txBody>
+      </p:sp>
+      <p:sp>
+        <p:nvSpPr>
+          <p:cNvPr id="13" name="Oval 12">
+            <a:extLst>
+              <a:ext uri="{FF2B5EF4-FFF2-40B4-BE49-F238E27FC236}">
+                <a16:creationId xmlns:a16="http://schemas.microsoft.com/office/drawing/2014/main" id="{F643948E-32DE-B6E7-A441-9CFE935B02F1}"/>
+              </a:ext>
+            </a:extLst>
+          </p:cNvPr>
+          <p:cNvSpPr/>
+          <p:nvPr/>
+        </p:nvSpPr>
+        <p:spPr>
+          <a:xfrm>
+            <a:off x="3460866" y="4042304"/>
+            <a:ext cx="266007" cy="224440"/>
+          </a:xfrm>
+          <a:prstGeom prst="ellipse">
+            <a:avLst/>
+          </a:prstGeom>
+        </p:spPr>
+        <p:style>
+          <a:lnRef idx="2">
+            <a:schemeClr val="accent1">
+              <a:shade val="15000"/>
+            </a:schemeClr>
+          </a:lnRef>
+          <a:fillRef idx="1">
+            <a:schemeClr val="accent1"/>
+          </a:fillRef>
+          <a:effectRef idx="0">
+            <a:schemeClr val="accent1"/>
+          </a:effectRef>
+          <a:fontRef idx="minor">
+            <a:schemeClr val="lt1"/>
+          </a:fontRef>
+        </p:style>
+        <p:txBody>
+          <a:bodyPr rtlCol="0" anchor="ctr"/>
+          <a:lstStyle/>
+          <a:p>
+            <a:pPr algn="ctr"/>
+            <a:endParaRPr lang="en-US"/>
+          </a:p>
+        </p:txBody>
+      </p:sp>
+      <p:sp>
+        <p:nvSpPr>
+          <p:cNvPr id="15" name="Oval 14">
+            <a:extLst>
+              <a:ext uri="{FF2B5EF4-FFF2-40B4-BE49-F238E27FC236}">
+                <a16:creationId xmlns:a16="http://schemas.microsoft.com/office/drawing/2014/main" id="{5233E5B6-DA5B-4CD9-32DF-F65BCC826034}"/>
+              </a:ext>
+            </a:extLst>
+          </p:cNvPr>
+          <p:cNvSpPr/>
+          <p:nvPr/>
+        </p:nvSpPr>
+        <p:spPr>
+          <a:xfrm>
+            <a:off x="9504913" y="4042304"/>
+            <a:ext cx="266007" cy="224440"/>
+          </a:xfrm>
+          <a:prstGeom prst="ellipse">
+            <a:avLst/>
+          </a:prstGeom>
+        </p:spPr>
+        <p:style>
+          <a:lnRef idx="2">
+            <a:schemeClr val="accent1">
+              <a:shade val="15000"/>
+            </a:schemeClr>
+          </a:lnRef>
+          <a:fillRef idx="1">
+            <a:schemeClr val="accent1"/>
+          </a:fillRef>
+          <a:effectRef idx="0">
+            <a:schemeClr val="accent1"/>
+          </a:effectRef>
+          <a:fontRef idx="minor">
+            <a:schemeClr val="lt1"/>
+          </a:fontRef>
+        </p:style>
+        <p:txBody>
+          <a:bodyPr rtlCol="0" anchor="ctr"/>
+          <a:lstStyle/>
+          <a:p>
+            <a:pPr algn="ctr"/>
+            <a:endParaRPr lang="en-US"/>
+          </a:p>
+        </p:txBody>
+      </p:sp>
+      <p:sp>
+        <p:nvSpPr>
+          <p:cNvPr id="19" name="Oval 18">
+            <a:extLst>
+              <a:ext uri="{FF2B5EF4-FFF2-40B4-BE49-F238E27FC236}">
+                <a16:creationId xmlns:a16="http://schemas.microsoft.com/office/drawing/2014/main" id="{610318E4-B241-9873-2323-AF18A1C8F5B2}"/>
+              </a:ext>
+            </a:extLst>
+          </p:cNvPr>
+          <p:cNvSpPr/>
+          <p:nvPr/>
+        </p:nvSpPr>
+        <p:spPr>
+          <a:xfrm>
+            <a:off x="4206241" y="4042304"/>
+            <a:ext cx="266007" cy="224440"/>
+          </a:xfrm>
+          <a:prstGeom prst="ellipse">
+            <a:avLst/>
+          </a:prstGeom>
+        </p:spPr>
+        <p:style>
+          <a:lnRef idx="2">
+            <a:schemeClr val="accent1">
+              <a:shade val="15000"/>
+            </a:schemeClr>
+          </a:lnRef>
+          <a:fillRef idx="1">
+            <a:schemeClr val="accent1"/>
+          </a:fillRef>
+          <a:effectRef idx="0">
+            <a:schemeClr val="accent1"/>
+          </a:effectRef>
+          <a:fontRef idx="minor">
+            <a:schemeClr val="lt1"/>
+          </a:fontRef>
+        </p:style>
+        <p:txBody>
+          <a:bodyPr rtlCol="0" anchor="ctr"/>
+          <a:lstStyle/>
+          <a:p>
+            <a:pPr algn="ctr"/>
+            <a:endParaRPr lang="en-US"/>
+          </a:p>
+        </p:txBody>
+      </p:sp>
+      <p:sp>
+        <p:nvSpPr>
+          <p:cNvPr id="21" name="TextBox 20">
+            <a:extLst>
+              <a:ext uri="{FF2B5EF4-FFF2-40B4-BE49-F238E27FC236}">
+                <a16:creationId xmlns:a16="http://schemas.microsoft.com/office/drawing/2014/main" id="{F02F36C2-2D8F-2AC1-3877-6355720DEC1F}"/>
+              </a:ext>
+            </a:extLst>
+          </p:cNvPr>
+          <p:cNvSpPr txBox="1"/>
+          <p:nvPr/>
+        </p:nvSpPr>
+        <p:spPr>
+          <a:xfrm flipH="1">
+            <a:off x="10480272" y="3862135"/>
+            <a:ext cx="336666" cy="584775"/>
+          </a:xfrm>
+          <a:prstGeom prst="rect">
+            <a:avLst/>
+          </a:prstGeom>
+          <a:noFill/>
+        </p:spPr>
+        <p:txBody>
+          <a:bodyPr wrap="square" rtlCol="0">
+            <a:spAutoFit/>
+          </a:bodyPr>
+          <a:lstStyle/>
+          <a:p>
+            <a:r>
+              <a:rPr lang="en-US" sz="3200" b="1" dirty="0"/>
+              <a:t>X</a:t>
+            </a:r>
+          </a:p>
+        </p:txBody>
+      </p:sp>
+      <p:sp>
+        <p:nvSpPr>
+          <p:cNvPr id="23" name="Rectangle 22">
+            <a:extLst>
+              <a:ext uri="{FF2B5EF4-FFF2-40B4-BE49-F238E27FC236}">
+                <a16:creationId xmlns:a16="http://schemas.microsoft.com/office/drawing/2014/main" id="{383645D3-1D9B-1530-CEFF-056BEB4C3B81}"/>
+              </a:ext>
+            </a:extLst>
+          </p:cNvPr>
+          <p:cNvSpPr/>
+          <p:nvPr/>
+        </p:nvSpPr>
+        <p:spPr>
+          <a:xfrm>
+            <a:off x="1612670" y="3925922"/>
+            <a:ext cx="1828800" cy="457200"/>
+          </a:xfrm>
+          <a:prstGeom prst="rect">
+            <a:avLst/>
+          </a:prstGeom>
+          <a:solidFill>
+            <a:schemeClr val="accent1">
+              <a:alpha val="37000"/>
+            </a:schemeClr>
+          </a:solidFill>
+        </p:spPr>
+        <p:style>
+          <a:lnRef idx="2">
+            <a:schemeClr val="accent1">
+              <a:shade val="15000"/>
+            </a:schemeClr>
+          </a:lnRef>
+          <a:fillRef idx="1">
+            <a:schemeClr val="accent1"/>
+          </a:fillRef>
+          <a:effectRef idx="0">
+            <a:schemeClr val="accent1"/>
+          </a:effectRef>
+          <a:fontRef idx="minor">
+            <a:schemeClr val="lt1"/>
+          </a:fontRef>
+        </p:style>
+        <p:txBody>
+          <a:bodyPr rtlCol="0" anchor="ctr"/>
+          <a:lstStyle/>
+          <a:p>
+            <a:pPr algn="ctr"/>
+            <a:r>
+              <a:rPr lang="en-US" dirty="0"/>
+              <a:t>14</a:t>
+            </a:r>
+          </a:p>
+        </p:txBody>
+      </p:sp>
+      <p:sp>
+        <p:nvSpPr>
+          <p:cNvPr id="25" name="Rectangle 24">
+            <a:extLst>
+              <a:ext uri="{FF2B5EF4-FFF2-40B4-BE49-F238E27FC236}">
+                <a16:creationId xmlns:a16="http://schemas.microsoft.com/office/drawing/2014/main" id="{B7AE8D27-94AF-2D55-C31E-40AFE7F2D91C}"/>
+              </a:ext>
+            </a:extLst>
+          </p:cNvPr>
+          <p:cNvSpPr/>
+          <p:nvPr/>
+        </p:nvSpPr>
+        <p:spPr>
+          <a:xfrm>
+            <a:off x="4378474" y="3925922"/>
+            <a:ext cx="1828800" cy="457200"/>
+          </a:xfrm>
+          <a:prstGeom prst="rect">
+            <a:avLst/>
+          </a:prstGeom>
+          <a:solidFill>
+            <a:schemeClr val="accent1">
+              <a:alpha val="37000"/>
+            </a:schemeClr>
+          </a:solidFill>
+        </p:spPr>
+        <p:style>
+          <a:lnRef idx="2">
+            <a:schemeClr val="accent1">
+              <a:shade val="15000"/>
+            </a:schemeClr>
+          </a:lnRef>
+          <a:fillRef idx="1">
+            <a:schemeClr val="accent1"/>
+          </a:fillRef>
+          <a:effectRef idx="0">
+            <a:schemeClr val="accent1"/>
+          </a:effectRef>
+          <a:fontRef idx="minor">
+            <a:schemeClr val="lt1"/>
+          </a:fontRef>
+        </p:style>
+        <p:txBody>
+          <a:bodyPr rtlCol="0" anchor="ctr"/>
+          <a:lstStyle/>
+          <a:p>
+            <a:pPr algn="ctr"/>
+            <a:r>
+              <a:rPr lang="en-US" dirty="0"/>
+              <a:t>14</a:t>
+            </a:r>
+          </a:p>
+        </p:txBody>
+      </p:sp>
+      <p:sp>
+        <p:nvSpPr>
+          <p:cNvPr id="26" name="Rectangle 25">
+            <a:extLst>
+              <a:ext uri="{FF2B5EF4-FFF2-40B4-BE49-F238E27FC236}">
+                <a16:creationId xmlns:a16="http://schemas.microsoft.com/office/drawing/2014/main" id="{1F7E33F3-F2BD-E2A8-0CDD-3B67761E78BE}"/>
+              </a:ext>
+            </a:extLst>
+          </p:cNvPr>
+          <p:cNvSpPr/>
+          <p:nvPr/>
+        </p:nvSpPr>
+        <p:spPr>
+          <a:xfrm>
+            <a:off x="9529505" y="3925922"/>
+            <a:ext cx="1126193" cy="457200"/>
+          </a:xfrm>
+          <a:prstGeom prst="rect">
+            <a:avLst/>
+          </a:prstGeom>
+          <a:solidFill>
+            <a:schemeClr val="accent1">
+              <a:alpha val="37000"/>
+            </a:schemeClr>
+          </a:solidFill>
+        </p:spPr>
+        <p:style>
+          <a:lnRef idx="2">
+            <a:schemeClr val="accent1">
+              <a:shade val="15000"/>
+            </a:schemeClr>
+          </a:lnRef>
+          <a:fillRef idx="1">
+            <a:schemeClr val="accent1"/>
+          </a:fillRef>
+          <a:effectRef idx="0">
+            <a:schemeClr val="accent1"/>
+          </a:effectRef>
+          <a:fontRef idx="minor">
+            <a:schemeClr val="lt1"/>
+          </a:fontRef>
+        </p:style>
+        <p:txBody>
+          <a:bodyPr rtlCol="0" anchor="ctr"/>
+          <a:lstStyle/>
+          <a:p>
+            <a:pPr algn="ctr"/>
+            <a:r>
+              <a:rPr lang="en-US" dirty="0"/>
+              <a:t>9</a:t>
+            </a:r>
+          </a:p>
+        </p:txBody>
+      </p:sp>
+      <p:sp>
+        <p:nvSpPr>
+          <p:cNvPr id="28" name="Rectangle 27">
+            <a:extLst>
+              <a:ext uri="{FF2B5EF4-FFF2-40B4-BE49-F238E27FC236}">
+                <a16:creationId xmlns:a16="http://schemas.microsoft.com/office/drawing/2014/main" id="{3DE0DD77-B458-6E1D-509A-D32CFFCA4F5F}"/>
+              </a:ext>
+            </a:extLst>
+          </p:cNvPr>
+          <p:cNvSpPr/>
+          <p:nvPr/>
+        </p:nvSpPr>
+        <p:spPr>
+          <a:xfrm>
+            <a:off x="3453773" y="3925922"/>
+            <a:ext cx="914400" cy="457200"/>
+          </a:xfrm>
+          <a:prstGeom prst="rect">
+            <a:avLst/>
+          </a:prstGeom>
+          <a:solidFill>
+            <a:schemeClr val="accent1">
+              <a:alpha val="37000"/>
+            </a:schemeClr>
+          </a:solidFill>
+        </p:spPr>
+        <p:style>
+          <a:lnRef idx="2">
+            <a:schemeClr val="accent1">
+              <a:shade val="15000"/>
+            </a:schemeClr>
+          </a:lnRef>
+          <a:fillRef idx="1">
+            <a:schemeClr val="accent1"/>
+          </a:fillRef>
+          <a:effectRef idx="0">
+            <a:schemeClr val="accent1"/>
+          </a:effectRef>
+          <a:fontRef idx="minor">
+            <a:schemeClr val="lt1"/>
+          </a:fontRef>
+        </p:style>
+        <p:txBody>
+          <a:bodyPr rtlCol="0" anchor="ctr"/>
+          <a:lstStyle/>
+          <a:p>
+            <a:pPr algn="ctr"/>
+            <a:r>
+              <a:rPr lang="en-US" dirty="0"/>
+              <a:t>7</a:t>
+            </a:r>
+          </a:p>
+        </p:txBody>
+      </p:sp>
+    </p:spTree>
+    <p:extLst>
+      <p:ext uri="{BB962C8B-B14F-4D97-AF65-F5344CB8AC3E}">
+        <p14:creationId xmlns:p14="http://schemas.microsoft.com/office/powerpoint/2010/main" val="3136643251"/>
+      </p:ext>
+    </p:extLst>
+  </p:cSld>
+  <p:clrMapOvr>
+    <a:masterClrMapping/>
+  </p:clrMapOvr>
+  <p:timing>
+    <p:tnLst>
+      <p:par>
+        <p:cTn id="1" dur="indefinite" restart="never" nodeType="tmRoot">
+          <p:childTnLst>
+            <p:seq concurrent="1" nextAc="seek">
+              <p:cTn id="2" dur="indefinite" nodeType="mainSeq">
+                <p:childTnLst>
+                  <p:par>
+                    <p:cTn id="3" fill="hold">
+                      <p:stCondLst>
+                        <p:cond delay="indefinite"/>
+                      </p:stCondLst>
+                      <p:childTnLst>
+                        <p:par>
+                          <p:cTn id="4" fill="hold">
+                            <p:stCondLst>
+                              <p:cond delay="0"/>
+                            </p:stCondLst>
+                            <p:childTnLst>
+                              <p:par>
+                                <p:cTn id="5" presetID="1" presetClass="entr" presetSubtype="0" fill="hold" grpId="0" nodeType="clickEffect">
+                                  <p:stCondLst>
+                                    <p:cond delay="0"/>
+                                  </p:stCondLst>
+                                  <p:childTnLst>
+                                    <p:set>
+                                      <p:cBhvr>
+                                        <p:cTn id="6" dur="1" fill="hold">
+                                          <p:stCondLst>
+                                            <p:cond delay="0"/>
+                                          </p:stCondLst>
+                                        </p:cTn>
+                                        <p:tgtEl>
+                                          <p:spTgt spid="18"/>
+                                        </p:tgtEl>
+                                        <p:attrNameLst>
+                                          <p:attrName>style.visibility</p:attrName>
+                                        </p:attrNameLst>
+                                      </p:cBhvr>
+                                      <p:to>
+                                        <p:strVal val="visible"/>
+                                      </p:to>
+                                    </p:set>
+                                  </p:childTnLst>
+                                </p:cTn>
+                              </p:par>
+                            </p:childTnLst>
+                          </p:cTn>
+                        </p:par>
+                        <p:par>
+                          <p:cTn id="7" fill="hold">
+                            <p:stCondLst>
+                              <p:cond delay="0"/>
+                            </p:stCondLst>
+                            <p:childTnLst>
+                              <p:par>
+                                <p:cTn id="8" presetID="1" presetClass="entr" presetSubtype="0" fill="hold" grpId="0" nodeType="afterEffect">
+                                  <p:stCondLst>
+                                    <p:cond delay="500"/>
+                                  </p:stCondLst>
+                                  <p:childTnLst>
+                                    <p:set>
+                                      <p:cBhvr>
+                                        <p:cTn id="9" dur="1" fill="hold">
+                                          <p:stCondLst>
+                                            <p:cond delay="0"/>
+                                          </p:stCondLst>
+                                        </p:cTn>
+                                        <p:tgtEl>
+                                          <p:spTgt spid="3"/>
+                                        </p:tgtEl>
+                                        <p:attrNameLst>
+                                          <p:attrName>style.visibility</p:attrName>
+                                        </p:attrNameLst>
+                                      </p:cBhvr>
+                                      <p:to>
+                                        <p:strVal val="visible"/>
+                                      </p:to>
+                                    </p:set>
+                                  </p:childTnLst>
+                                </p:cTn>
+                              </p:par>
+                            </p:childTnLst>
+                          </p:cTn>
+                        </p:par>
+                        <p:par>
+                          <p:cTn id="10" fill="hold">
+                            <p:stCondLst>
+                              <p:cond delay="500"/>
+                            </p:stCondLst>
+                            <p:childTnLst>
+                              <p:par>
+                                <p:cTn id="11" presetID="1" presetClass="entr" presetSubtype="0" fill="hold" grpId="0" nodeType="afterEffect">
+                                  <p:stCondLst>
+                                    <p:cond delay="500"/>
+                                  </p:stCondLst>
+                                  <p:childTnLst>
+                                    <p:set>
+                                      <p:cBhvr>
+                                        <p:cTn id="12" dur="1" fill="hold">
+                                          <p:stCondLst>
+                                            <p:cond delay="0"/>
+                                          </p:stCondLst>
+                                        </p:cTn>
+                                        <p:tgtEl>
+                                          <p:spTgt spid="5"/>
+                                        </p:tgtEl>
+                                        <p:attrNameLst>
+                                          <p:attrName>style.visibility</p:attrName>
+                                        </p:attrNameLst>
+                                      </p:cBhvr>
+                                      <p:to>
+                                        <p:strVal val="visible"/>
+                                      </p:to>
+                                    </p:set>
+                                  </p:childTnLst>
+                                </p:cTn>
+                              </p:par>
+                            </p:childTnLst>
+                          </p:cTn>
+                        </p:par>
+                        <p:par>
+                          <p:cTn id="13" fill="hold">
+                            <p:stCondLst>
+                              <p:cond delay="1000"/>
+                            </p:stCondLst>
+                            <p:childTnLst>
+                              <p:par>
+                                <p:cTn id="14" presetID="1" presetClass="entr" presetSubtype="0" fill="hold" grpId="0" nodeType="afterEffect">
+                                  <p:stCondLst>
+                                    <p:cond delay="500"/>
+                                  </p:stCondLst>
+                                  <p:childTnLst>
+                                    <p:set>
+                                      <p:cBhvr>
+                                        <p:cTn id="15" dur="1" fill="hold">
+                                          <p:stCondLst>
+                                            <p:cond delay="0"/>
+                                          </p:stCondLst>
+                                        </p:cTn>
+                                        <p:tgtEl>
+                                          <p:spTgt spid="9"/>
+                                        </p:tgtEl>
+                                        <p:attrNameLst>
+                                          <p:attrName>style.visibility</p:attrName>
+                                        </p:attrNameLst>
+                                      </p:cBhvr>
+                                      <p:to>
+                                        <p:strVal val="visible"/>
+                                      </p:to>
+                                    </p:set>
+                                  </p:childTnLst>
+                                </p:cTn>
+                              </p:par>
+                            </p:childTnLst>
+                          </p:cTn>
+                        </p:par>
+                        <p:par>
+                          <p:cTn id="16" fill="hold">
+                            <p:stCondLst>
+                              <p:cond delay="1500"/>
+                            </p:stCondLst>
+                            <p:childTnLst>
+                              <p:par>
+                                <p:cTn id="17" presetID="1" presetClass="entr" presetSubtype="0" fill="hold" grpId="0" nodeType="afterEffect">
+                                  <p:stCondLst>
+                                    <p:cond delay="500"/>
+                                  </p:stCondLst>
+                                  <p:childTnLst>
+                                    <p:set>
+                                      <p:cBhvr>
+                                        <p:cTn id="18" dur="1" fill="hold">
+                                          <p:stCondLst>
+                                            <p:cond delay="0"/>
+                                          </p:stCondLst>
+                                        </p:cTn>
+                                        <p:tgtEl>
+                                          <p:spTgt spid="23"/>
+                                        </p:tgtEl>
+                                        <p:attrNameLst>
+                                          <p:attrName>style.visibility</p:attrName>
+                                        </p:attrNameLst>
+                                      </p:cBhvr>
+                                      <p:to>
+                                        <p:strVal val="visible"/>
+                                      </p:to>
+                                    </p:set>
+                                  </p:childTnLst>
+                                </p:cTn>
+                              </p:par>
+                            </p:childTnLst>
+                          </p:cTn>
+                        </p:par>
+                        <p:par>
+                          <p:cTn id="19" fill="hold">
+                            <p:stCondLst>
+                              <p:cond delay="2000"/>
+                            </p:stCondLst>
+                            <p:childTnLst>
+                              <p:par>
+                                <p:cTn id="20" presetID="1" presetClass="entr" presetSubtype="0" fill="hold" grpId="0" nodeType="afterEffect">
+                                  <p:stCondLst>
+                                    <p:cond delay="500"/>
+                                  </p:stCondLst>
+                                  <p:childTnLst>
+                                    <p:set>
+                                      <p:cBhvr>
+                                        <p:cTn id="21" dur="1" fill="hold">
+                                          <p:stCondLst>
+                                            <p:cond delay="0"/>
+                                          </p:stCondLst>
+                                        </p:cTn>
+                                        <p:tgtEl>
+                                          <p:spTgt spid="28"/>
+                                        </p:tgtEl>
+                                        <p:attrNameLst>
+                                          <p:attrName>style.visibility</p:attrName>
+                                        </p:attrNameLst>
+                                      </p:cBhvr>
+                                      <p:to>
+                                        <p:strVal val="visible"/>
+                                      </p:to>
+                                    </p:set>
+                                  </p:childTnLst>
+                                </p:cTn>
+                              </p:par>
+                            </p:childTnLst>
+                          </p:cTn>
+                        </p:par>
+                        <p:par>
+                          <p:cTn id="22" fill="hold">
+                            <p:stCondLst>
+                              <p:cond delay="2500"/>
+                            </p:stCondLst>
+                            <p:childTnLst>
+                              <p:par>
+                                <p:cTn id="23" presetID="1" presetClass="entr" presetSubtype="0" fill="hold" grpId="0" nodeType="afterEffect">
+                                  <p:stCondLst>
+                                    <p:cond delay="500"/>
+                                  </p:stCondLst>
+                                  <p:childTnLst>
+                                    <p:set>
+                                      <p:cBhvr>
+                                        <p:cTn id="24" dur="1" fill="hold">
+                                          <p:stCondLst>
+                                            <p:cond delay="0"/>
+                                          </p:stCondLst>
+                                        </p:cTn>
+                                        <p:tgtEl>
+                                          <p:spTgt spid="25"/>
+                                        </p:tgtEl>
+                                        <p:attrNameLst>
+                                          <p:attrName>style.visibility</p:attrName>
+                                        </p:attrNameLst>
+                                      </p:cBhvr>
+                                      <p:to>
+                                        <p:strVal val="visible"/>
+                                      </p:to>
+                                    </p:set>
+                                  </p:childTnLst>
+                                </p:cTn>
+                              </p:par>
+                            </p:childTnLst>
+                          </p:cTn>
+                        </p:par>
+                        <p:par>
+                          <p:cTn id="25" fill="hold">
+                            <p:stCondLst>
+                              <p:cond delay="3000"/>
+                            </p:stCondLst>
+                            <p:childTnLst>
+                              <p:par>
+                                <p:cTn id="26" presetID="1" presetClass="entr" presetSubtype="0" fill="hold" grpId="0" nodeType="afterEffect">
+                                  <p:stCondLst>
+                                    <p:cond delay="500"/>
+                                  </p:stCondLst>
+                                  <p:childTnLst>
+                                    <p:set>
+                                      <p:cBhvr>
+                                        <p:cTn id="27" dur="1" fill="hold">
+                                          <p:stCondLst>
+                                            <p:cond delay="0"/>
+                                          </p:stCondLst>
+                                        </p:cTn>
+                                        <p:tgtEl>
+                                          <p:spTgt spid="26"/>
+                                        </p:tgtEl>
+                                        <p:attrNameLst>
+                                          <p:attrName>style.visibility</p:attrName>
+                                        </p:attrNameLst>
+                                      </p:cBhvr>
+                                      <p:to>
+                                        <p:strVal val="visible"/>
+                                      </p:to>
+                                    </p:set>
+                                  </p:childTnLst>
+                                </p:cTn>
+                              </p:par>
+                            </p:childTnLst>
+                          </p:cTn>
+                        </p:par>
+                      </p:childTnLst>
+                    </p:cTn>
+                  </p:par>
+                </p:childTnLst>
+              </p:cTn>
+              <p:prevCondLst>
+                <p:cond evt="onPrev" delay="0">
+                  <p:tgtEl>
+                    <p:sldTgt/>
+                  </p:tgtEl>
+                </p:cond>
+              </p:prevCondLst>
+              <p:nextCondLst>
+                <p:cond evt="onNext" delay="0">
+                  <p:tgtEl>
+                    <p:sldTgt/>
+                  </p:tgtEl>
+                </p:cond>
+              </p:nextCondLst>
+            </p:seq>
+          </p:childTnLst>
+        </p:cTn>
+      </p:par>
+    </p:tnLst>
+    <p:bldLst>
+      <p:bldP spid="18" grpId="0" animBg="1"/>
+      <p:bldP spid="3" grpId="0" animBg="1"/>
+      <p:bldP spid="5" grpId="0" animBg="1"/>
+      <p:bldP spid="9" grpId="0" animBg="1"/>
+      <p:bldP spid="23" grpId="0" animBg="1"/>
+      <p:bldP spid="25" grpId="0" animBg="1"/>
+      <p:bldP spid="26" grpId="0" animBg="1"/>
+      <p:bldP spid="28" grpId="0" animBg="1"/>
+    </p:bldLst>
+  </p:timing>
+</p:sld>
+</file>
+
+<file path=ppt/slides/slide4.xml><?xml version="1.0" encoding="utf-8"?>
+<p:sld xmlns:a="http://schemas.openxmlformats.org/drawingml/2006/main" xmlns:r="http://schemas.openxmlformats.org/officeDocument/2006/relationships" xmlns:p="http://schemas.openxmlformats.org/presentationml/2006/main">
+  <p:cSld>
+    <p:spTree>
+      <p:nvGrpSpPr>
+        <p:cNvPr id="1" name="">
+          <a:extLst>
+            <a:ext uri="{FF2B5EF4-FFF2-40B4-BE49-F238E27FC236}">
+              <a16:creationId xmlns:a16="http://schemas.microsoft.com/office/drawing/2014/main" id="{244E8169-84BB-B919-F494-8C91D4C2BB0C}"/>
+            </a:ext>
+          </a:extLst>
+        </p:cNvPr>
+        <p:cNvGrpSpPr/>
+        <p:nvPr/>
+      </p:nvGrpSpPr>
+      <p:grpSpPr>
+        <a:xfrm>
+          <a:off x="0" y="0"/>
+          <a:ext cx="0" cy="0"/>
+          <a:chOff x="0" y="0"/>
+          <a:chExt cx="0" cy="0"/>
+        </a:xfrm>
+      </p:grpSpPr>
+      <p:cxnSp>
+        <p:nvCxnSpPr>
+          <p:cNvPr id="7" name="Straight Connector 6">
+            <a:extLst>
+              <a:ext uri="{FF2B5EF4-FFF2-40B4-BE49-F238E27FC236}">
+                <a16:creationId xmlns:a16="http://schemas.microsoft.com/office/drawing/2014/main" id="{9BEE6812-F3C3-5A6A-069F-67E3E50CAE98}"/>
+              </a:ext>
+            </a:extLst>
+          </p:cNvPr>
+          <p:cNvCxnSpPr/>
+          <p:nvPr/>
+        </p:nvCxnSpPr>
+        <p:spPr>
+          <a:xfrm>
+            <a:off x="1745674" y="3050773"/>
+            <a:ext cx="8902931" cy="0"/>
+          </a:xfrm>
+          <a:prstGeom prst="line">
+            <a:avLst/>
+          </a:prstGeom>
+          <a:ln w="38100">
+            <a:solidFill>
+              <a:schemeClr val="tx1"/>
+            </a:solidFill>
+            <a:headEnd type="none" w="med" len="med"/>
+            <a:tailEnd type="triangle" w="med" len="med"/>
+          </a:ln>
+        </p:spPr>
+        <p:style>
+          <a:lnRef idx="1">
+            <a:schemeClr val="accent1"/>
+          </a:lnRef>
+          <a:fillRef idx="0">
+            <a:schemeClr val="accent1"/>
+          </a:fillRef>
+          <a:effectRef idx="0">
+            <a:schemeClr val="accent1"/>
+          </a:effectRef>
+          <a:fontRef idx="minor">
+            <a:schemeClr val="tx1"/>
+          </a:fontRef>
+        </p:style>
+      </p:cxnSp>
+      <p:sp>
+        <p:nvSpPr>
+          <p:cNvPr id="8" name="Oval 7">
+            <a:extLst>
+              <a:ext uri="{FF2B5EF4-FFF2-40B4-BE49-F238E27FC236}">
+                <a16:creationId xmlns:a16="http://schemas.microsoft.com/office/drawing/2014/main" id="{D282C358-82CB-980E-DF10-786C6FDA974E}"/>
+              </a:ext>
+            </a:extLst>
+          </p:cNvPr>
+          <p:cNvSpPr/>
+          <p:nvPr/>
+        </p:nvSpPr>
+        <p:spPr>
+          <a:xfrm>
+            <a:off x="1612670" y="2938553"/>
+            <a:ext cx="266007" cy="224440"/>
+          </a:xfrm>
+          <a:prstGeom prst="ellipse">
+            <a:avLst/>
+          </a:prstGeom>
+        </p:spPr>
+        <p:style>
+          <a:lnRef idx="2">
+            <a:schemeClr val="accent1">
+              <a:shade val="15000"/>
+            </a:schemeClr>
+          </a:lnRef>
+          <a:fillRef idx="1">
+            <a:schemeClr val="accent1"/>
+          </a:fillRef>
+          <a:effectRef idx="0">
+            <a:schemeClr val="accent1"/>
+          </a:effectRef>
+          <a:fontRef idx="minor">
+            <a:schemeClr val="lt1"/>
+          </a:fontRef>
+        </p:style>
+        <p:txBody>
+          <a:bodyPr rtlCol="0" anchor="ctr"/>
+          <a:lstStyle/>
+          <a:p>
+            <a:pPr algn="ctr"/>
+            <a:endParaRPr lang="en-US"/>
+          </a:p>
+        </p:txBody>
+      </p:sp>
+      <p:sp>
+        <p:nvSpPr>
+          <p:cNvPr id="10" name="Oval 9">
+            <a:extLst>
+              <a:ext uri="{FF2B5EF4-FFF2-40B4-BE49-F238E27FC236}">
+                <a16:creationId xmlns:a16="http://schemas.microsoft.com/office/drawing/2014/main" id="{0DE567EB-31AF-C0F9-4E5D-1B1BC4C5311E}"/>
+              </a:ext>
+            </a:extLst>
+          </p:cNvPr>
+          <p:cNvSpPr/>
+          <p:nvPr/>
+        </p:nvSpPr>
+        <p:spPr>
+          <a:xfrm>
+            <a:off x="3460866" y="2938553"/>
+            <a:ext cx="266007" cy="224440"/>
+          </a:xfrm>
+          <a:prstGeom prst="ellipse">
+            <a:avLst/>
+          </a:prstGeom>
+        </p:spPr>
+        <p:style>
+          <a:lnRef idx="2">
+            <a:schemeClr val="accent1">
+              <a:shade val="15000"/>
+            </a:schemeClr>
+          </a:lnRef>
+          <a:fillRef idx="1">
+            <a:schemeClr val="accent1"/>
+          </a:fillRef>
+          <a:effectRef idx="0">
+            <a:schemeClr val="accent1"/>
+          </a:effectRef>
+          <a:fontRef idx="minor">
+            <a:schemeClr val="lt1"/>
+          </a:fontRef>
+        </p:style>
+        <p:txBody>
+          <a:bodyPr rtlCol="0" anchor="ctr"/>
+          <a:lstStyle/>
+          <a:p>
+            <a:pPr algn="ctr"/>
+            <a:endParaRPr lang="en-US"/>
+          </a:p>
+        </p:txBody>
+      </p:sp>
+      <p:sp>
+        <p:nvSpPr>
+          <p:cNvPr id="14" name="Oval 13">
+            <a:extLst>
+              <a:ext uri="{FF2B5EF4-FFF2-40B4-BE49-F238E27FC236}">
+                <a16:creationId xmlns:a16="http://schemas.microsoft.com/office/drawing/2014/main" id="{4E2EEA2F-131E-0FB7-7E32-E3D3ADFE37CF}"/>
+              </a:ext>
+            </a:extLst>
+          </p:cNvPr>
+          <p:cNvSpPr/>
+          <p:nvPr/>
+        </p:nvSpPr>
+        <p:spPr>
+          <a:xfrm>
+            <a:off x="9504913" y="2938553"/>
+            <a:ext cx="266007" cy="224440"/>
+          </a:xfrm>
+          <a:prstGeom prst="ellipse">
+            <a:avLst/>
+          </a:prstGeom>
+        </p:spPr>
+        <p:style>
+          <a:lnRef idx="2">
+            <a:schemeClr val="accent1">
+              <a:shade val="15000"/>
+            </a:schemeClr>
+          </a:lnRef>
+          <a:fillRef idx="1">
+            <a:schemeClr val="accent1"/>
+          </a:fillRef>
+          <a:effectRef idx="0">
+            <a:schemeClr val="accent1"/>
+          </a:effectRef>
+          <a:fontRef idx="minor">
+            <a:schemeClr val="lt1"/>
+          </a:fontRef>
+        </p:style>
+        <p:txBody>
+          <a:bodyPr rtlCol="0" anchor="ctr"/>
+          <a:lstStyle/>
+          <a:p>
+            <a:pPr algn="ctr"/>
+            <a:endParaRPr lang="en-US"/>
+          </a:p>
+        </p:txBody>
+      </p:sp>
+      <p:sp>
+        <p:nvSpPr>
+          <p:cNvPr id="16" name="Oval 15">
+            <a:extLst>
+              <a:ext uri="{FF2B5EF4-FFF2-40B4-BE49-F238E27FC236}">
+                <a16:creationId xmlns:a16="http://schemas.microsoft.com/office/drawing/2014/main" id="{8B97CBDF-E2E9-2FC8-3F20-700CC4098891}"/>
+              </a:ext>
+            </a:extLst>
+          </p:cNvPr>
+          <p:cNvSpPr/>
+          <p:nvPr/>
+        </p:nvSpPr>
+        <p:spPr>
+          <a:xfrm>
+            <a:off x="4206241" y="2938553"/>
+            <a:ext cx="266007" cy="224440"/>
+          </a:xfrm>
+          <a:prstGeom prst="ellipse">
+            <a:avLst/>
+          </a:prstGeom>
+        </p:spPr>
+        <p:style>
+          <a:lnRef idx="2">
+            <a:schemeClr val="accent1">
+              <a:shade val="15000"/>
+            </a:schemeClr>
+          </a:lnRef>
+          <a:fillRef idx="1">
+            <a:schemeClr val="accent1"/>
+          </a:fillRef>
+          <a:effectRef idx="0">
+            <a:schemeClr val="accent1"/>
+          </a:effectRef>
+          <a:fontRef idx="minor">
+            <a:schemeClr val="lt1"/>
+          </a:fontRef>
+        </p:style>
+        <p:txBody>
+          <a:bodyPr rtlCol="0" anchor="ctr"/>
+          <a:lstStyle/>
+          <a:p>
+            <a:pPr algn="ctr"/>
+            <a:endParaRPr lang="en-US"/>
+          </a:p>
+        </p:txBody>
+      </p:sp>
+      <p:sp>
+        <p:nvSpPr>
+          <p:cNvPr id="17" name="TextBox 16">
+            <a:extLst>
+              <a:ext uri="{FF2B5EF4-FFF2-40B4-BE49-F238E27FC236}">
+                <a16:creationId xmlns:a16="http://schemas.microsoft.com/office/drawing/2014/main" id="{22B5B6DE-381B-804C-7EA4-EF481FC9182D}"/>
+              </a:ext>
+            </a:extLst>
+          </p:cNvPr>
+          <p:cNvSpPr txBox="1"/>
+          <p:nvPr/>
+        </p:nvSpPr>
+        <p:spPr>
+          <a:xfrm flipH="1">
+            <a:off x="10480272" y="2758384"/>
+            <a:ext cx="336666" cy="584775"/>
+          </a:xfrm>
+          <a:prstGeom prst="rect">
+            <a:avLst/>
+          </a:prstGeom>
+          <a:noFill/>
+        </p:spPr>
+        <p:txBody>
+          <a:bodyPr wrap="square" rtlCol="0">
+            <a:spAutoFit/>
+          </a:bodyPr>
+          <a:lstStyle/>
+          <a:p>
+            <a:r>
+              <a:rPr lang="en-US" sz="3200" b="1" dirty="0"/>
+              <a:t>X</a:t>
+            </a:r>
+          </a:p>
+        </p:txBody>
+      </p:sp>
+      <p:sp>
+        <p:nvSpPr>
+          <p:cNvPr id="18" name="Rectangle 17">
+            <a:extLst>
+              <a:ext uri="{FF2B5EF4-FFF2-40B4-BE49-F238E27FC236}">
+                <a16:creationId xmlns:a16="http://schemas.microsoft.com/office/drawing/2014/main" id="{D0C39F93-1BED-2701-88E6-174CB96D4256}"/>
+              </a:ext>
+            </a:extLst>
+          </p:cNvPr>
+          <p:cNvSpPr/>
+          <p:nvPr/>
+        </p:nvSpPr>
+        <p:spPr>
+          <a:xfrm>
+            <a:off x="1612670" y="2822171"/>
+            <a:ext cx="914400" cy="457200"/>
+          </a:xfrm>
+          <a:prstGeom prst="rect">
+            <a:avLst/>
+          </a:prstGeom>
+          <a:solidFill>
+            <a:schemeClr val="accent1">
+              <a:alpha val="37000"/>
+            </a:schemeClr>
+          </a:solidFill>
+        </p:spPr>
+        <p:style>
+          <a:lnRef idx="2">
+            <a:schemeClr val="accent1">
+              <a:shade val="15000"/>
+            </a:schemeClr>
+          </a:lnRef>
+          <a:fillRef idx="1">
+            <a:schemeClr val="accent1"/>
+          </a:fillRef>
+          <a:effectRef idx="0">
+            <a:schemeClr val="accent1"/>
+          </a:effectRef>
+          <a:fontRef idx="minor">
+            <a:schemeClr val="lt1"/>
+          </a:fontRef>
+        </p:style>
+        <p:txBody>
+          <a:bodyPr rtlCol="0" anchor="ctr"/>
+          <a:lstStyle/>
+          <a:p>
+            <a:pPr algn="ctr"/>
+            <a:r>
+              <a:rPr lang="en-US" dirty="0"/>
+              <a:t>7</a:t>
+            </a:r>
+          </a:p>
+        </p:txBody>
+      </p:sp>
+      <p:sp>
+        <p:nvSpPr>
+          <p:cNvPr id="3" name="Rectangle 2">
+            <a:extLst>
+              <a:ext uri="{FF2B5EF4-FFF2-40B4-BE49-F238E27FC236}">
+                <a16:creationId xmlns:a16="http://schemas.microsoft.com/office/drawing/2014/main" id="{F6009168-C786-11A6-00F6-0C0B70BE6B8A}"/>
+              </a:ext>
+            </a:extLst>
+          </p:cNvPr>
+          <p:cNvSpPr/>
+          <p:nvPr/>
+        </p:nvSpPr>
+        <p:spPr>
+          <a:xfrm>
+            <a:off x="3460866" y="2822171"/>
+            <a:ext cx="914400" cy="457200"/>
+          </a:xfrm>
+          <a:prstGeom prst="rect">
+            <a:avLst/>
+          </a:prstGeom>
+          <a:solidFill>
+            <a:schemeClr val="accent1">
+              <a:alpha val="37000"/>
+            </a:schemeClr>
+          </a:solidFill>
+        </p:spPr>
+        <p:style>
+          <a:lnRef idx="2">
+            <a:schemeClr val="accent1">
+              <a:shade val="15000"/>
+            </a:schemeClr>
+          </a:lnRef>
+          <a:fillRef idx="1">
+            <a:schemeClr val="accent1"/>
+          </a:fillRef>
+          <a:effectRef idx="0">
+            <a:schemeClr val="accent1"/>
+          </a:effectRef>
+          <a:fontRef idx="minor">
+            <a:schemeClr val="lt1"/>
+          </a:fontRef>
+        </p:style>
+        <p:txBody>
+          <a:bodyPr rtlCol="0" anchor="ctr"/>
+          <a:lstStyle/>
+          <a:p>
+            <a:pPr algn="ctr"/>
+            <a:r>
+              <a:rPr lang="en-US" dirty="0"/>
+              <a:t>7</a:t>
+            </a:r>
+          </a:p>
+        </p:txBody>
+      </p:sp>
+      <p:sp>
+        <p:nvSpPr>
+          <p:cNvPr id="5" name="Rectangle 4">
+            <a:extLst>
+              <a:ext uri="{FF2B5EF4-FFF2-40B4-BE49-F238E27FC236}">
+                <a16:creationId xmlns:a16="http://schemas.microsoft.com/office/drawing/2014/main" id="{3166A15A-1E5E-B5F5-BDE1-B86520D0C365}"/>
+              </a:ext>
+            </a:extLst>
+          </p:cNvPr>
+          <p:cNvSpPr/>
+          <p:nvPr/>
+        </p:nvSpPr>
+        <p:spPr>
+          <a:xfrm>
+            <a:off x="4378474" y="2822171"/>
+            <a:ext cx="914400" cy="457200"/>
+          </a:xfrm>
+          <a:prstGeom prst="rect">
+            <a:avLst/>
+          </a:prstGeom>
+          <a:solidFill>
+            <a:schemeClr val="accent1">
+              <a:alpha val="37000"/>
+            </a:schemeClr>
+          </a:solidFill>
+        </p:spPr>
+        <p:style>
+          <a:lnRef idx="2">
+            <a:schemeClr val="accent1">
+              <a:shade val="15000"/>
+            </a:schemeClr>
+          </a:lnRef>
+          <a:fillRef idx="1">
+            <a:schemeClr val="accent1"/>
+          </a:fillRef>
+          <a:effectRef idx="0">
+            <a:schemeClr val="accent1"/>
+          </a:effectRef>
+          <a:fontRef idx="minor">
+            <a:schemeClr val="lt1"/>
+          </a:fontRef>
+        </p:style>
+        <p:txBody>
+          <a:bodyPr rtlCol="0" anchor="ctr"/>
+          <a:lstStyle/>
+          <a:p>
+            <a:pPr algn="ctr"/>
+            <a:r>
+              <a:rPr lang="en-US" dirty="0"/>
+              <a:t>7</a:t>
+            </a:r>
+          </a:p>
+        </p:txBody>
+      </p:sp>
+      <p:sp>
+        <p:nvSpPr>
+          <p:cNvPr id="9" name="Rectangle 8">
+            <a:extLst>
+              <a:ext uri="{FF2B5EF4-FFF2-40B4-BE49-F238E27FC236}">
+                <a16:creationId xmlns:a16="http://schemas.microsoft.com/office/drawing/2014/main" id="{BFD777CA-3E4B-5571-4BD9-39B5ED422A92}"/>
+              </a:ext>
+            </a:extLst>
+          </p:cNvPr>
+          <p:cNvSpPr/>
+          <p:nvPr/>
+        </p:nvSpPr>
+        <p:spPr>
+          <a:xfrm>
+            <a:off x="9529505" y="2822171"/>
+            <a:ext cx="914400" cy="457200"/>
+          </a:xfrm>
+          <a:prstGeom prst="rect">
+            <a:avLst/>
+          </a:prstGeom>
+          <a:solidFill>
+            <a:schemeClr val="accent1">
+              <a:alpha val="37000"/>
+            </a:schemeClr>
+          </a:solidFill>
+        </p:spPr>
+        <p:style>
+          <a:lnRef idx="2">
+            <a:schemeClr val="accent1">
+              <a:shade val="15000"/>
+            </a:schemeClr>
+          </a:lnRef>
+          <a:fillRef idx="1">
+            <a:schemeClr val="accent1"/>
+          </a:fillRef>
+          <a:effectRef idx="0">
+            <a:schemeClr val="accent1"/>
+          </a:effectRef>
+          <a:fontRef idx="minor">
+            <a:schemeClr val="lt1"/>
+          </a:fontRef>
+        </p:style>
+        <p:txBody>
+          <a:bodyPr rtlCol="0" anchor="ctr"/>
+          <a:lstStyle/>
+          <a:p>
+            <a:pPr algn="ctr"/>
+            <a:r>
+              <a:rPr lang="en-US" dirty="0"/>
+              <a:t>7</a:t>
+            </a:r>
+          </a:p>
+        </p:txBody>
+      </p:sp>
+      <p:cxnSp>
+        <p:nvCxnSpPr>
+          <p:cNvPr id="11" name="Straight Connector 10">
+            <a:extLst>
+              <a:ext uri="{FF2B5EF4-FFF2-40B4-BE49-F238E27FC236}">
+                <a16:creationId xmlns:a16="http://schemas.microsoft.com/office/drawing/2014/main" id="{F081D4FD-0605-0F23-2E0F-48625B06FB5C}"/>
+              </a:ext>
+            </a:extLst>
+          </p:cNvPr>
+          <p:cNvCxnSpPr/>
+          <p:nvPr/>
+        </p:nvCxnSpPr>
+        <p:spPr>
+          <a:xfrm>
+            <a:off x="1745674" y="4154524"/>
+            <a:ext cx="8902931" cy="0"/>
+          </a:xfrm>
+          <a:prstGeom prst="line">
+            <a:avLst/>
+          </a:prstGeom>
+          <a:ln w="38100">
+            <a:solidFill>
+              <a:schemeClr val="tx1"/>
+            </a:solidFill>
+            <a:headEnd type="none" w="med" len="med"/>
+            <a:tailEnd type="triangle" w="med" len="med"/>
+          </a:ln>
+        </p:spPr>
+        <p:style>
+          <a:lnRef idx="1">
+            <a:schemeClr val="accent1"/>
+          </a:lnRef>
+          <a:fillRef idx="0">
+            <a:schemeClr val="accent1"/>
+          </a:fillRef>
+          <a:effectRef idx="0">
+            <a:schemeClr val="accent1"/>
+          </a:effectRef>
+          <a:fontRef idx="minor">
+            <a:schemeClr val="tx1"/>
+          </a:fontRef>
+        </p:style>
+      </p:cxnSp>
+      <p:sp>
+        <p:nvSpPr>
+          <p:cNvPr id="12" name="Oval 11">
+            <a:extLst>
+              <a:ext uri="{FF2B5EF4-FFF2-40B4-BE49-F238E27FC236}">
+                <a16:creationId xmlns:a16="http://schemas.microsoft.com/office/drawing/2014/main" id="{72179614-6353-18BB-DD47-5BFE3CD26BD7}"/>
+              </a:ext>
+            </a:extLst>
+          </p:cNvPr>
+          <p:cNvSpPr/>
+          <p:nvPr/>
+        </p:nvSpPr>
+        <p:spPr>
+          <a:xfrm>
+            <a:off x="1612670" y="4042304"/>
+            <a:ext cx="266007" cy="224440"/>
+          </a:xfrm>
+          <a:prstGeom prst="ellipse">
+            <a:avLst/>
+          </a:prstGeom>
+        </p:spPr>
+        <p:style>
+          <a:lnRef idx="2">
+            <a:schemeClr val="accent1">
+              <a:shade val="15000"/>
+            </a:schemeClr>
+          </a:lnRef>
+          <a:fillRef idx="1">
+            <a:schemeClr val="accent1"/>
+          </a:fillRef>
+          <a:effectRef idx="0">
+            <a:schemeClr val="accent1"/>
+          </a:effectRef>
+          <a:fontRef idx="minor">
+            <a:schemeClr val="lt1"/>
+          </a:fontRef>
+        </p:style>
+        <p:txBody>
+          <a:bodyPr rtlCol="0" anchor="ctr"/>
+          <a:lstStyle/>
+          <a:p>
+            <a:pPr algn="ctr"/>
+            <a:endParaRPr lang="en-US"/>
+          </a:p>
+        </p:txBody>
+      </p:sp>
+      <p:sp>
+        <p:nvSpPr>
+          <p:cNvPr id="13" name="Oval 12">
+            <a:extLst>
+              <a:ext uri="{FF2B5EF4-FFF2-40B4-BE49-F238E27FC236}">
+                <a16:creationId xmlns:a16="http://schemas.microsoft.com/office/drawing/2014/main" id="{1613E562-752F-3174-DA05-71D7856F2AA9}"/>
+              </a:ext>
+            </a:extLst>
+          </p:cNvPr>
+          <p:cNvSpPr/>
+          <p:nvPr/>
+        </p:nvSpPr>
+        <p:spPr>
+          <a:xfrm>
+            <a:off x="3460866" y="4042304"/>
+            <a:ext cx="266007" cy="224440"/>
+          </a:xfrm>
+          <a:prstGeom prst="ellipse">
+            <a:avLst/>
+          </a:prstGeom>
+        </p:spPr>
+        <p:style>
+          <a:lnRef idx="2">
+            <a:schemeClr val="accent1">
+              <a:shade val="15000"/>
+            </a:schemeClr>
+          </a:lnRef>
+          <a:fillRef idx="1">
+            <a:schemeClr val="accent1"/>
+          </a:fillRef>
+          <a:effectRef idx="0">
+            <a:schemeClr val="accent1"/>
+          </a:effectRef>
+          <a:fontRef idx="minor">
+            <a:schemeClr val="lt1"/>
+          </a:fontRef>
+        </p:style>
+        <p:txBody>
+          <a:bodyPr rtlCol="0" anchor="ctr"/>
+          <a:lstStyle/>
+          <a:p>
+            <a:pPr algn="ctr"/>
+            <a:endParaRPr lang="en-US"/>
+          </a:p>
+        </p:txBody>
+      </p:sp>
+      <p:sp>
+        <p:nvSpPr>
+          <p:cNvPr id="15" name="Oval 14">
+            <a:extLst>
+              <a:ext uri="{FF2B5EF4-FFF2-40B4-BE49-F238E27FC236}">
+                <a16:creationId xmlns:a16="http://schemas.microsoft.com/office/drawing/2014/main" id="{D7BF18D1-6770-89C9-0CD0-C1EE30D72157}"/>
+              </a:ext>
+            </a:extLst>
+          </p:cNvPr>
+          <p:cNvSpPr/>
+          <p:nvPr/>
+        </p:nvSpPr>
+        <p:spPr>
+          <a:xfrm>
+            <a:off x="9504913" y="4042304"/>
+            <a:ext cx="266007" cy="224440"/>
+          </a:xfrm>
+          <a:prstGeom prst="ellipse">
+            <a:avLst/>
+          </a:prstGeom>
+        </p:spPr>
+        <p:style>
+          <a:lnRef idx="2">
+            <a:schemeClr val="accent1">
+              <a:shade val="15000"/>
+            </a:schemeClr>
+          </a:lnRef>
+          <a:fillRef idx="1">
+            <a:schemeClr val="accent1"/>
+          </a:fillRef>
+          <a:effectRef idx="0">
+            <a:schemeClr val="accent1"/>
+          </a:effectRef>
+          <a:fontRef idx="minor">
+            <a:schemeClr val="lt1"/>
+          </a:fontRef>
+        </p:style>
+        <p:txBody>
+          <a:bodyPr rtlCol="0" anchor="ctr"/>
+          <a:lstStyle/>
+          <a:p>
+            <a:pPr algn="ctr"/>
+            <a:endParaRPr lang="en-US"/>
+          </a:p>
+        </p:txBody>
+      </p:sp>
+      <p:sp>
+        <p:nvSpPr>
+          <p:cNvPr id="19" name="Oval 18">
+            <a:extLst>
+              <a:ext uri="{FF2B5EF4-FFF2-40B4-BE49-F238E27FC236}">
+                <a16:creationId xmlns:a16="http://schemas.microsoft.com/office/drawing/2014/main" id="{881E5818-E03A-5DF9-F071-A8C52ED07AC5}"/>
+              </a:ext>
+            </a:extLst>
+          </p:cNvPr>
+          <p:cNvSpPr/>
+          <p:nvPr/>
+        </p:nvSpPr>
+        <p:spPr>
+          <a:xfrm>
+            <a:off x="4206241" y="4042304"/>
+            <a:ext cx="266007" cy="224440"/>
+          </a:xfrm>
+          <a:prstGeom prst="ellipse">
+            <a:avLst/>
+          </a:prstGeom>
+        </p:spPr>
+        <p:style>
+          <a:lnRef idx="2">
+            <a:schemeClr val="accent1">
+              <a:shade val="15000"/>
+            </a:schemeClr>
+          </a:lnRef>
+          <a:fillRef idx="1">
+            <a:schemeClr val="accent1"/>
+          </a:fillRef>
+          <a:effectRef idx="0">
+            <a:schemeClr val="accent1"/>
+          </a:effectRef>
+          <a:fontRef idx="minor">
+            <a:schemeClr val="lt1"/>
+          </a:fontRef>
+        </p:style>
+        <p:txBody>
+          <a:bodyPr rtlCol="0" anchor="ctr"/>
+          <a:lstStyle/>
+          <a:p>
+            <a:pPr algn="ctr"/>
+            <a:endParaRPr lang="en-US"/>
+          </a:p>
+        </p:txBody>
+      </p:sp>
+      <p:sp>
+        <p:nvSpPr>
+          <p:cNvPr id="21" name="TextBox 20">
+            <a:extLst>
+              <a:ext uri="{FF2B5EF4-FFF2-40B4-BE49-F238E27FC236}">
+                <a16:creationId xmlns:a16="http://schemas.microsoft.com/office/drawing/2014/main" id="{D04F6A7C-14DC-0F3C-D091-409B1A6CE930}"/>
+              </a:ext>
+            </a:extLst>
+          </p:cNvPr>
+          <p:cNvSpPr txBox="1"/>
+          <p:nvPr/>
+        </p:nvSpPr>
+        <p:spPr>
+          <a:xfrm flipH="1">
+            <a:off x="10480272" y="3862135"/>
+            <a:ext cx="336666" cy="584775"/>
+          </a:xfrm>
+          <a:prstGeom prst="rect">
+            <a:avLst/>
+          </a:prstGeom>
+          <a:noFill/>
+        </p:spPr>
+        <p:txBody>
+          <a:bodyPr wrap="square" rtlCol="0">
+            <a:spAutoFit/>
+          </a:bodyPr>
+          <a:lstStyle/>
+          <a:p>
+            <a:r>
+              <a:rPr lang="en-US" sz="3200" b="1" dirty="0"/>
+              <a:t>X</a:t>
+            </a:r>
+          </a:p>
+        </p:txBody>
+      </p:sp>
+      <p:sp>
+        <p:nvSpPr>
+          <p:cNvPr id="23" name="Rectangle 22">
+            <a:extLst>
+              <a:ext uri="{FF2B5EF4-FFF2-40B4-BE49-F238E27FC236}">
+                <a16:creationId xmlns:a16="http://schemas.microsoft.com/office/drawing/2014/main" id="{DDB1FD31-9964-014E-0D5A-70BD571B3357}"/>
+              </a:ext>
+            </a:extLst>
+          </p:cNvPr>
+          <p:cNvSpPr/>
+          <p:nvPr/>
+        </p:nvSpPr>
+        <p:spPr>
+          <a:xfrm>
+            <a:off x="1612670" y="3925922"/>
+            <a:ext cx="1828800" cy="457200"/>
+          </a:xfrm>
+          <a:prstGeom prst="rect">
+            <a:avLst/>
+          </a:prstGeom>
+          <a:solidFill>
+            <a:srgbClr val="00B050">
+              <a:alpha val="37000"/>
+            </a:srgbClr>
+          </a:solidFill>
+        </p:spPr>
+        <p:style>
+          <a:lnRef idx="2">
+            <a:schemeClr val="accent1">
+              <a:shade val="15000"/>
+            </a:schemeClr>
+          </a:lnRef>
+          <a:fillRef idx="1">
+            <a:schemeClr val="accent1"/>
+          </a:fillRef>
+          <a:effectRef idx="0">
+            <a:schemeClr val="accent1"/>
+          </a:effectRef>
+          <a:fontRef idx="minor">
+            <a:schemeClr val="lt1"/>
+          </a:fontRef>
+        </p:style>
+        <p:txBody>
+          <a:bodyPr rtlCol="0" anchor="ctr"/>
+          <a:lstStyle/>
+          <a:p>
+            <a:pPr algn="ctr"/>
+            <a:r>
+              <a:rPr lang="en-US" dirty="0"/>
+              <a:t>14</a:t>
+            </a:r>
+          </a:p>
+        </p:txBody>
+      </p:sp>
+      <p:sp>
+        <p:nvSpPr>
+          <p:cNvPr id="25" name="Rectangle 24">
+            <a:extLst>
+              <a:ext uri="{FF2B5EF4-FFF2-40B4-BE49-F238E27FC236}">
+                <a16:creationId xmlns:a16="http://schemas.microsoft.com/office/drawing/2014/main" id="{A22ADB74-FEA1-E120-C625-F83646DB4D10}"/>
+              </a:ext>
+            </a:extLst>
+          </p:cNvPr>
+          <p:cNvSpPr/>
+          <p:nvPr/>
+        </p:nvSpPr>
+        <p:spPr>
+          <a:xfrm>
+            <a:off x="4378474" y="3925922"/>
+            <a:ext cx="1828800" cy="457200"/>
+          </a:xfrm>
+          <a:prstGeom prst="rect">
+            <a:avLst/>
+          </a:prstGeom>
+          <a:solidFill>
+            <a:srgbClr val="00B050">
+              <a:alpha val="37000"/>
+            </a:srgbClr>
+          </a:solidFill>
+        </p:spPr>
+        <p:style>
+          <a:lnRef idx="2">
+            <a:schemeClr val="accent1">
+              <a:shade val="15000"/>
+            </a:schemeClr>
+          </a:lnRef>
+          <a:fillRef idx="1">
+            <a:schemeClr val="accent1"/>
+          </a:fillRef>
+          <a:effectRef idx="0">
+            <a:schemeClr val="accent1"/>
+          </a:effectRef>
+          <a:fontRef idx="minor">
+            <a:schemeClr val="lt1"/>
+          </a:fontRef>
+        </p:style>
+        <p:txBody>
+          <a:bodyPr rtlCol="0" anchor="ctr"/>
+          <a:lstStyle/>
+          <a:p>
+            <a:pPr algn="ctr"/>
+            <a:r>
+              <a:rPr lang="en-US" dirty="0"/>
+              <a:t>14</a:t>
+            </a:r>
+          </a:p>
+        </p:txBody>
+      </p:sp>
+      <p:sp>
+        <p:nvSpPr>
+          <p:cNvPr id="26" name="Rectangle 25">
+            <a:extLst>
+              <a:ext uri="{FF2B5EF4-FFF2-40B4-BE49-F238E27FC236}">
+                <a16:creationId xmlns:a16="http://schemas.microsoft.com/office/drawing/2014/main" id="{CF9F10E5-3E2E-F0F8-27D6-5689E1691208}"/>
+              </a:ext>
+            </a:extLst>
+          </p:cNvPr>
+          <p:cNvSpPr/>
+          <p:nvPr/>
+        </p:nvSpPr>
+        <p:spPr>
+          <a:xfrm>
+            <a:off x="9529505" y="3925922"/>
+            <a:ext cx="1126193" cy="457200"/>
+          </a:xfrm>
+          <a:prstGeom prst="rect">
+            <a:avLst/>
+          </a:prstGeom>
+          <a:solidFill>
+            <a:schemeClr val="accent1">
+              <a:alpha val="37000"/>
+            </a:schemeClr>
+          </a:solidFill>
+        </p:spPr>
+        <p:style>
+          <a:lnRef idx="2">
+            <a:schemeClr val="accent1">
+              <a:shade val="15000"/>
+            </a:schemeClr>
+          </a:lnRef>
+          <a:fillRef idx="1">
+            <a:schemeClr val="accent1"/>
+          </a:fillRef>
+          <a:effectRef idx="0">
+            <a:schemeClr val="accent1"/>
+          </a:effectRef>
+          <a:fontRef idx="minor">
+            <a:schemeClr val="lt1"/>
+          </a:fontRef>
+        </p:style>
+        <p:txBody>
+          <a:bodyPr rtlCol="0" anchor="ctr"/>
+          <a:lstStyle/>
+          <a:p>
+            <a:pPr algn="ctr"/>
+            <a:r>
+              <a:rPr lang="en-US" dirty="0"/>
+              <a:t>9</a:t>
+            </a:r>
+          </a:p>
+        </p:txBody>
+      </p:sp>
+      <p:sp>
+        <p:nvSpPr>
+          <p:cNvPr id="28" name="Rectangle 27">
+            <a:extLst>
+              <a:ext uri="{FF2B5EF4-FFF2-40B4-BE49-F238E27FC236}">
+                <a16:creationId xmlns:a16="http://schemas.microsoft.com/office/drawing/2014/main" id="{E56BD1A1-1E81-6445-83D9-19D9821AEDE8}"/>
+              </a:ext>
+            </a:extLst>
+          </p:cNvPr>
+          <p:cNvSpPr/>
+          <p:nvPr/>
+        </p:nvSpPr>
+        <p:spPr>
+          <a:xfrm>
+            <a:off x="3453773" y="3925922"/>
+            <a:ext cx="914400" cy="457200"/>
+          </a:xfrm>
+          <a:prstGeom prst="rect">
+            <a:avLst/>
+          </a:prstGeom>
+          <a:solidFill>
+            <a:schemeClr val="accent2">
+              <a:alpha val="37000"/>
+            </a:schemeClr>
+          </a:solidFill>
+        </p:spPr>
+        <p:style>
+          <a:lnRef idx="2">
+            <a:schemeClr val="accent1">
+              <a:shade val="15000"/>
+            </a:schemeClr>
+          </a:lnRef>
+          <a:fillRef idx="1">
+            <a:schemeClr val="accent1"/>
+          </a:fillRef>
+          <a:effectRef idx="0">
+            <a:schemeClr val="accent1"/>
+          </a:effectRef>
+          <a:fontRef idx="minor">
+            <a:schemeClr val="lt1"/>
+          </a:fontRef>
+        </p:style>
+        <p:txBody>
+          <a:bodyPr rtlCol="0" anchor="ctr"/>
+          <a:lstStyle/>
+          <a:p>
+            <a:pPr algn="ctr"/>
+            <a:r>
+              <a:rPr lang="en-US" dirty="0"/>
+              <a:t>7</a:t>
+            </a:r>
+          </a:p>
+        </p:txBody>
+      </p:sp>
+    </p:spTree>
+    <p:extLst>
+      <p:ext uri="{BB962C8B-B14F-4D97-AF65-F5344CB8AC3E}">
+        <p14:creationId xmlns:p14="http://schemas.microsoft.com/office/powerpoint/2010/main" val="2980907560"/>
+      </p:ext>
+    </p:extLst>
+  </p:cSld>
+  <p:clrMapOvr>
+    <a:masterClrMapping/>
+  </p:clrMapOvr>
+  <p:timing>
+    <p:tnLst>
+      <p:par>
+        <p:cTn id="1" dur="indefinite" restart="never" nodeType="tmRoot">
+          <p:childTnLst>
+            <p:seq concurrent="1" nextAc="seek">
+              <p:cTn id="2" dur="indefinite" nodeType="mainSeq">
+                <p:childTnLst>
+                  <p:par>
+                    <p:cTn id="3" fill="hold">
+                      <p:stCondLst>
+                        <p:cond delay="indefinite"/>
+                      </p:stCondLst>
+                      <p:childTnLst>
+                        <p:par>
+                          <p:cTn id="4" fill="hold">
+                            <p:stCondLst>
+                              <p:cond delay="0"/>
+                            </p:stCondLst>
+                            <p:childTnLst>
+                              <p:par>
+                                <p:cTn id="5" presetID="1" presetClass="entr" presetSubtype="0" fill="hold" grpId="0" nodeType="clickEffect">
+                                  <p:stCondLst>
+                                    <p:cond delay="0"/>
+                                  </p:stCondLst>
+                                  <p:childTnLst>
+                                    <p:set>
+                                      <p:cBhvr>
+                                        <p:cTn id="6" dur="1" fill="hold">
+                                          <p:stCondLst>
+                                            <p:cond delay="0"/>
+                                          </p:stCondLst>
+                                        </p:cTn>
+                                        <p:tgtEl>
+                                          <p:spTgt spid="18"/>
+                                        </p:tgtEl>
+                                        <p:attrNameLst>
+                                          <p:attrName>style.visibility</p:attrName>
+                                        </p:attrNameLst>
+                                      </p:cBhvr>
+                                      <p:to>
+                                        <p:strVal val="visible"/>
+                                      </p:to>
+                                    </p:set>
+                                  </p:childTnLst>
+                                </p:cTn>
+                              </p:par>
+                            </p:childTnLst>
+                          </p:cTn>
+                        </p:par>
+                        <p:par>
+                          <p:cTn id="7" fill="hold">
+                            <p:stCondLst>
+                              <p:cond delay="0"/>
+                            </p:stCondLst>
+                            <p:childTnLst>
+                              <p:par>
+                                <p:cTn id="8" presetID="1" presetClass="entr" presetSubtype="0" fill="hold" grpId="0" nodeType="afterEffect">
+                                  <p:stCondLst>
+                                    <p:cond delay="500"/>
+                                  </p:stCondLst>
+                                  <p:childTnLst>
+                                    <p:set>
+                                      <p:cBhvr>
+                                        <p:cTn id="9" dur="1" fill="hold">
+                                          <p:stCondLst>
+                                            <p:cond delay="0"/>
+                                          </p:stCondLst>
+                                        </p:cTn>
+                                        <p:tgtEl>
+                                          <p:spTgt spid="3"/>
+                                        </p:tgtEl>
+                                        <p:attrNameLst>
+                                          <p:attrName>style.visibility</p:attrName>
+                                        </p:attrNameLst>
+                                      </p:cBhvr>
+                                      <p:to>
+                                        <p:strVal val="visible"/>
+                                      </p:to>
+                                    </p:set>
+                                  </p:childTnLst>
+                                </p:cTn>
+                              </p:par>
+                            </p:childTnLst>
+                          </p:cTn>
+                        </p:par>
+                        <p:par>
+                          <p:cTn id="10" fill="hold">
+                            <p:stCondLst>
+                              <p:cond delay="500"/>
+                            </p:stCondLst>
+                            <p:childTnLst>
+                              <p:par>
+                                <p:cTn id="11" presetID="1" presetClass="entr" presetSubtype="0" fill="hold" grpId="0" nodeType="afterEffect">
+                                  <p:stCondLst>
+                                    <p:cond delay="500"/>
+                                  </p:stCondLst>
+                                  <p:childTnLst>
+                                    <p:set>
+                                      <p:cBhvr>
+                                        <p:cTn id="12" dur="1" fill="hold">
+                                          <p:stCondLst>
+                                            <p:cond delay="0"/>
+                                          </p:stCondLst>
+                                        </p:cTn>
+                                        <p:tgtEl>
+                                          <p:spTgt spid="5"/>
+                                        </p:tgtEl>
+                                        <p:attrNameLst>
+                                          <p:attrName>style.visibility</p:attrName>
+                                        </p:attrNameLst>
+                                      </p:cBhvr>
+                                      <p:to>
+                                        <p:strVal val="visible"/>
+                                      </p:to>
+                                    </p:set>
+                                  </p:childTnLst>
+                                </p:cTn>
+                              </p:par>
+                            </p:childTnLst>
+                          </p:cTn>
+                        </p:par>
+                        <p:par>
+                          <p:cTn id="13" fill="hold">
+                            <p:stCondLst>
+                              <p:cond delay="1000"/>
+                            </p:stCondLst>
+                            <p:childTnLst>
+                              <p:par>
+                                <p:cTn id="14" presetID="1" presetClass="entr" presetSubtype="0" fill="hold" grpId="0" nodeType="afterEffect">
+                                  <p:stCondLst>
+                                    <p:cond delay="500"/>
+                                  </p:stCondLst>
+                                  <p:childTnLst>
+                                    <p:set>
+                                      <p:cBhvr>
+                                        <p:cTn id="15" dur="1" fill="hold">
+                                          <p:stCondLst>
+                                            <p:cond delay="0"/>
+                                          </p:stCondLst>
+                                        </p:cTn>
+                                        <p:tgtEl>
+                                          <p:spTgt spid="9"/>
+                                        </p:tgtEl>
+                                        <p:attrNameLst>
+                                          <p:attrName>style.visibility</p:attrName>
+                                        </p:attrNameLst>
+                                      </p:cBhvr>
+                                      <p:to>
+                                        <p:strVal val="visible"/>
+                                      </p:to>
+                                    </p:set>
+                                  </p:childTnLst>
+                                </p:cTn>
+                              </p:par>
+                            </p:childTnLst>
+                          </p:cTn>
+                        </p:par>
+                        <p:par>
+                          <p:cTn id="16" fill="hold">
+                            <p:stCondLst>
+                              <p:cond delay="1500"/>
+                            </p:stCondLst>
+                            <p:childTnLst>
+                              <p:par>
+                                <p:cTn id="17" presetID="1" presetClass="entr" presetSubtype="0" fill="hold" grpId="0" nodeType="afterEffect">
+                                  <p:stCondLst>
+                                    <p:cond delay="500"/>
+                                  </p:stCondLst>
+                                  <p:childTnLst>
+                                    <p:set>
+                                      <p:cBhvr>
+                                        <p:cTn id="18" dur="1" fill="hold">
+                                          <p:stCondLst>
+                                            <p:cond delay="0"/>
+                                          </p:stCondLst>
+                                        </p:cTn>
+                                        <p:tgtEl>
+                                          <p:spTgt spid="23"/>
+                                        </p:tgtEl>
+                                        <p:attrNameLst>
+                                          <p:attrName>style.visibility</p:attrName>
+                                        </p:attrNameLst>
+                                      </p:cBhvr>
+                                      <p:to>
+                                        <p:strVal val="visible"/>
+                                      </p:to>
+                                    </p:set>
+                                  </p:childTnLst>
+                                </p:cTn>
+                              </p:par>
+                            </p:childTnLst>
+                          </p:cTn>
+                        </p:par>
+                        <p:par>
+                          <p:cTn id="19" fill="hold">
+                            <p:stCondLst>
+                              <p:cond delay="2000"/>
+                            </p:stCondLst>
+                            <p:childTnLst>
+                              <p:par>
+                                <p:cTn id="20" presetID="1" presetClass="entr" presetSubtype="0" fill="hold" grpId="0" nodeType="afterEffect">
+                                  <p:stCondLst>
+                                    <p:cond delay="500"/>
+                                  </p:stCondLst>
+                                  <p:childTnLst>
+                                    <p:set>
+                                      <p:cBhvr>
+                                        <p:cTn id="21" dur="1" fill="hold">
+                                          <p:stCondLst>
+                                            <p:cond delay="0"/>
+                                          </p:stCondLst>
+                                        </p:cTn>
+                                        <p:tgtEl>
+                                          <p:spTgt spid="28"/>
+                                        </p:tgtEl>
+                                        <p:attrNameLst>
+                                          <p:attrName>style.visibility</p:attrName>
+                                        </p:attrNameLst>
+                                      </p:cBhvr>
+                                      <p:to>
+                                        <p:strVal val="visible"/>
+                                      </p:to>
+                                    </p:set>
+                                  </p:childTnLst>
+                                </p:cTn>
+                              </p:par>
+                            </p:childTnLst>
+                          </p:cTn>
+                        </p:par>
+                        <p:par>
+                          <p:cTn id="22" fill="hold">
+                            <p:stCondLst>
+                              <p:cond delay="2500"/>
+                            </p:stCondLst>
+                            <p:childTnLst>
+                              <p:par>
+                                <p:cTn id="23" presetID="1" presetClass="entr" presetSubtype="0" fill="hold" grpId="0" nodeType="afterEffect">
+                                  <p:stCondLst>
+                                    <p:cond delay="500"/>
+                                  </p:stCondLst>
+                                  <p:childTnLst>
+                                    <p:set>
+                                      <p:cBhvr>
+                                        <p:cTn id="24" dur="1" fill="hold">
+                                          <p:stCondLst>
+                                            <p:cond delay="0"/>
+                                          </p:stCondLst>
+                                        </p:cTn>
+                                        <p:tgtEl>
+                                          <p:spTgt spid="25"/>
+                                        </p:tgtEl>
+                                        <p:attrNameLst>
+                                          <p:attrName>style.visibility</p:attrName>
+                                        </p:attrNameLst>
+                                      </p:cBhvr>
+                                      <p:to>
+                                        <p:strVal val="visible"/>
+                                      </p:to>
+                                    </p:set>
+                                  </p:childTnLst>
+                                </p:cTn>
+                              </p:par>
+                            </p:childTnLst>
+                          </p:cTn>
+                        </p:par>
+                        <p:par>
+                          <p:cTn id="25" fill="hold">
+                            <p:stCondLst>
+                              <p:cond delay="3000"/>
+                            </p:stCondLst>
+                            <p:childTnLst>
+                              <p:par>
+                                <p:cTn id="26" presetID="1" presetClass="entr" presetSubtype="0" fill="hold" grpId="0" nodeType="afterEffect">
+                                  <p:stCondLst>
+                                    <p:cond delay="500"/>
+                                  </p:stCondLst>
+                                  <p:childTnLst>
+                                    <p:set>
+                                      <p:cBhvr>
+                                        <p:cTn id="27" dur="1" fill="hold">
+                                          <p:stCondLst>
+                                            <p:cond delay="0"/>
+                                          </p:stCondLst>
+                                        </p:cTn>
+                                        <p:tgtEl>
+                                          <p:spTgt spid="26"/>
+                                        </p:tgtEl>
+                                        <p:attrNameLst>
+                                          <p:attrName>style.visibility</p:attrName>
+                                        </p:attrNameLst>
+                                      </p:cBhvr>
+                                      <p:to>
+                                        <p:strVal val="visible"/>
+                                      </p:to>
+                                    </p:set>
+                                  </p:childTnLst>
+                                </p:cTn>
+                              </p:par>
+                            </p:childTnLst>
+                          </p:cTn>
+                        </p:par>
+                      </p:childTnLst>
+                    </p:cTn>
+                  </p:par>
+                </p:childTnLst>
+              </p:cTn>
+              <p:prevCondLst>
+                <p:cond evt="onPrev" delay="0">
+                  <p:tgtEl>
+                    <p:sldTgt/>
+                  </p:tgtEl>
+                </p:cond>
+              </p:prevCondLst>
+              <p:nextCondLst>
+                <p:cond evt="onNext" delay="0">
+                  <p:tgtEl>
+                    <p:sldTgt/>
+                  </p:tgtEl>
+                </p:cond>
+              </p:nextCondLst>
+            </p:seq>
+          </p:childTnLst>
+        </p:cTn>
+      </p:par>
+    </p:tnLst>
+    <p:bldLst>
+      <p:bldP spid="18" grpId="0" animBg="1"/>
+      <p:bldP spid="3" grpId="0" animBg="1"/>
+      <p:bldP spid="5" grpId="0" animBg="1"/>
+      <p:bldP spid="9" grpId="0" animBg="1"/>
+      <p:bldP spid="23" grpId="0" animBg="1"/>
+      <p:bldP spid="25" grpId="0" animBg="1"/>
+      <p:bldP spid="26" grpId="0" animBg="1"/>
+      <p:bldP spid="28" grpId="0" animBg="1"/>
+    </p:bldLst>
+  </p:timing>
+</p:sld>
+</file>
+
+<file path=ppt/slides/slide5.xml><?xml version="1.0" encoding="utf-8"?>
+<p:sld xmlns:a="http://schemas.openxmlformats.org/drawingml/2006/main" xmlns:r="http://schemas.openxmlformats.org/officeDocument/2006/relationships" xmlns:p="http://schemas.openxmlformats.org/presentationml/2006/main">
+  <p:cSld>
+    <p:spTree>
+      <p:nvGrpSpPr>
+        <p:cNvPr id="1" name="">
+          <a:extLst>
+            <a:ext uri="{FF2B5EF4-FFF2-40B4-BE49-F238E27FC236}">
+              <a16:creationId xmlns:a16="http://schemas.microsoft.com/office/drawing/2014/main" id="{2067B4AB-B75C-DCCE-F746-ADAFDCCD3333}"/>
+            </a:ext>
+          </a:extLst>
+        </p:cNvPr>
+        <p:cNvGrpSpPr/>
+        <p:nvPr/>
+      </p:nvGrpSpPr>
+      <p:grpSpPr>
+        <a:xfrm>
+          <a:off x="0" y="0"/>
+          <a:ext cx="0" cy="0"/>
+          <a:chOff x="0" y="0"/>
+          <a:chExt cx="0" cy="0"/>
+        </a:xfrm>
+      </p:grpSpPr>
       <p:pic>
         <p:nvPicPr>
-          <p:cNvPr id="5" name="Picture 4">
-            <a:extLst>
-              <a:ext uri="{FF2B5EF4-FFF2-40B4-BE49-F238E27FC236}">
-                <a16:creationId xmlns:a16="http://schemas.microsoft.com/office/drawing/2014/main" id="{F02195D8-5A1A-39A0-B724-D01DB19D4BC7}"/>
+          <p:cNvPr id="3" name="Picture 2">
+            <a:extLst>
+              <a:ext uri="{FF2B5EF4-FFF2-40B4-BE49-F238E27FC236}">
+                <a16:creationId xmlns:a16="http://schemas.microsoft.com/office/drawing/2014/main" id="{0EF9D5ED-B59C-9BA0-21D8-345601D67A9C}"/>
               </a:ext>
             </a:extLst>
           </p:cNvPr>
@@ -3506,8 +7379,8 @@
         </p:blipFill>
         <p:spPr>
           <a:xfrm>
-            <a:off x="108066" y="1027906"/>
-            <a:ext cx="12192000" cy="4600238"/>
+            <a:off x="0" y="709921"/>
+            <a:ext cx="12192000" cy="5438158"/>
           </a:xfrm>
           <a:prstGeom prst="rect">
             <a:avLst/>
@@ -3517,7 +7390,7 @@
     </p:spTree>
     <p:extLst>
       <p:ext uri="{BB962C8B-B14F-4D97-AF65-F5344CB8AC3E}">
-        <p14:creationId xmlns:p14="http://schemas.microsoft.com/office/powerpoint/2010/main" val="2266987066"/>
+        <p14:creationId xmlns:p14="http://schemas.microsoft.com/office/powerpoint/2010/main" val="1348516141"/>
       </p:ext>
     </p:extLst>
   </p:cSld>
@@ -3527,7 +7400,7 @@
 </p:sld>
 </file>
 
-<file path=ppt/slides/slide3.xml><?xml version="1.0" encoding="utf-8"?>
+<file path=ppt/slides/slide6.xml><?xml version="1.0" encoding="utf-8"?>
 <p:sld xmlns:a="http://schemas.openxmlformats.org/drawingml/2006/main" xmlns:r="http://schemas.openxmlformats.org/officeDocument/2006/relationships" xmlns:p="http://schemas.openxmlformats.org/presentationml/2006/main">
   <p:cSld>
     <p:spTree>
@@ -3549,7 +7422,7 @@
           <p:cNvPr id="3" name="Picture 2">
             <a:extLst>
               <a:ext uri="{FF2B5EF4-FFF2-40B4-BE49-F238E27FC236}">
-                <a16:creationId xmlns:a16="http://schemas.microsoft.com/office/drawing/2014/main" id="{AE8B3F95-6D06-5841-2036-01FB1B229380}"/>
+                <a16:creationId xmlns:a16="http://schemas.microsoft.com/office/drawing/2014/main" id="{A9BE7F4C-7BD6-5770-C0B6-615CD140210C}"/>
               </a:ext>
             </a:extLst>
           </p:cNvPr>
@@ -3566,8 +7439,8 @@
         </p:blipFill>
         <p:spPr>
           <a:xfrm>
-            <a:off x="0" y="832868"/>
-            <a:ext cx="12192000" cy="5192263"/>
+            <a:off x="0" y="691397"/>
+            <a:ext cx="12192000" cy="5475205"/>
           </a:xfrm>
           <a:prstGeom prst="rect">
             <a:avLst/>
@@ -3577,7 +7450,7 @@
     </p:spTree>
     <p:extLst>
       <p:ext uri="{BB962C8B-B14F-4D97-AF65-F5344CB8AC3E}">
-        <p14:creationId xmlns:p14="http://schemas.microsoft.com/office/powerpoint/2010/main" val="990378249"/>
+        <p14:creationId xmlns:p14="http://schemas.microsoft.com/office/powerpoint/2010/main" val="4261648169"/>
       </p:ext>
     </p:extLst>
   </p:cSld>
@@ -3587,12 +7460,18 @@
 </p:sld>
 </file>
 
-<file path=ppt/slides/slide4.xml><?xml version="1.0" encoding="utf-8"?>
+<file path=ppt/slides/slide7.xml><?xml version="1.0" encoding="utf-8"?>
 <p:sld xmlns:a="http://schemas.openxmlformats.org/drawingml/2006/main" xmlns:r="http://schemas.openxmlformats.org/officeDocument/2006/relationships" xmlns:p="http://schemas.openxmlformats.org/presentationml/2006/main">
   <p:cSld>
     <p:spTree>
       <p:nvGrpSpPr>
-        <p:cNvPr id="1" name=""/>
+        <p:cNvPr id="1" name="">
+          <a:extLst>
+            <a:ext uri="{FF2B5EF4-FFF2-40B4-BE49-F238E27FC236}">
+              <a16:creationId xmlns:a16="http://schemas.microsoft.com/office/drawing/2014/main" id="{65556CD9-84D3-AFA1-A763-7FB484C0B6C2}"/>
+            </a:ext>
+          </a:extLst>
+        </p:cNvPr>
         <p:cNvGrpSpPr/>
         <p:nvPr/>
       </p:nvGrpSpPr>
@@ -3609,7 +7488,7 @@
           <p:cNvPr id="3" name="Picture 2">
             <a:extLst>
               <a:ext uri="{FF2B5EF4-FFF2-40B4-BE49-F238E27FC236}">
-                <a16:creationId xmlns:a16="http://schemas.microsoft.com/office/drawing/2014/main" id="{9EAFA21A-8A8E-E0D3-1742-3DBC572A2A3D}"/>
+                <a16:creationId xmlns:a16="http://schemas.microsoft.com/office/drawing/2014/main" id="{D4B7E668-042C-8EA7-C040-63BDC4523FCC}"/>
               </a:ext>
             </a:extLst>
           </p:cNvPr>
@@ -3626,8 +7505,8 @@
         </p:blipFill>
         <p:spPr>
           <a:xfrm>
-            <a:off x="0" y="653447"/>
-            <a:ext cx="12192000" cy="5551106"/>
+            <a:off x="0" y="716280"/>
+            <a:ext cx="12192000" cy="5425440"/>
           </a:xfrm>
           <a:prstGeom prst="rect">
             <a:avLst/>
@@ -3637,7 +7516,109 @@
     </p:spTree>
     <p:extLst>
       <p:ext uri="{BB962C8B-B14F-4D97-AF65-F5344CB8AC3E}">
-        <p14:creationId xmlns:p14="http://schemas.microsoft.com/office/powerpoint/2010/main" val="1615924507"/>
+        <p14:creationId xmlns:p14="http://schemas.microsoft.com/office/powerpoint/2010/main" val="2930873069"/>
+      </p:ext>
+    </p:extLst>
+  </p:cSld>
+  <p:clrMapOvr>
+    <a:masterClrMapping/>
+  </p:clrMapOvr>
+</p:sld>
+</file>
+
+<file path=ppt/slides/slide8.xml><?xml version="1.0" encoding="utf-8"?>
+<p:sld xmlns:a="http://schemas.openxmlformats.org/drawingml/2006/main" xmlns:r="http://schemas.openxmlformats.org/officeDocument/2006/relationships" xmlns:p="http://schemas.openxmlformats.org/presentationml/2006/main">
+  <p:cSld>
+    <p:spTree>
+      <p:nvGrpSpPr>
+        <p:cNvPr id="1" name="">
+          <a:extLst>
+            <a:ext uri="{FF2B5EF4-FFF2-40B4-BE49-F238E27FC236}">
+              <a16:creationId xmlns:a16="http://schemas.microsoft.com/office/drawing/2014/main" id="{FE60F587-5A8B-BE29-4E75-087141B677D7}"/>
+            </a:ext>
+          </a:extLst>
+        </p:cNvPr>
+        <p:cNvGrpSpPr/>
+        <p:nvPr/>
+      </p:nvGrpSpPr>
+      <p:grpSpPr>
+        <a:xfrm>
+          <a:off x="0" y="0"/>
+          <a:ext cx="0" cy="0"/>
+          <a:chOff x="0" y="0"/>
+          <a:chExt cx="0" cy="0"/>
+        </a:xfrm>
+      </p:grpSpPr>
+      <p:pic>
+        <p:nvPicPr>
+          <p:cNvPr id="3" name="Picture 2">
+            <a:extLst>
+              <a:ext uri="{FF2B5EF4-FFF2-40B4-BE49-F238E27FC236}">
+                <a16:creationId xmlns:a16="http://schemas.microsoft.com/office/drawing/2014/main" id="{703DB33A-7AE9-808D-B1E9-834562918281}"/>
+              </a:ext>
+            </a:extLst>
+          </p:cNvPr>
+          <p:cNvPicPr>
+            <a:picLocks noChangeAspect="1"/>
+          </p:cNvPicPr>
+          <p:nvPr/>
+        </p:nvPicPr>
+        <p:blipFill>
+          <a:blip r:embed="rId2"/>
+          <a:stretch>
+            <a:fillRect/>
+          </a:stretch>
+        </p:blipFill>
+        <p:spPr>
+          <a:xfrm>
+            <a:off x="0" y="510198"/>
+            <a:ext cx="12192000" cy="5837603"/>
+          </a:xfrm>
+          <a:prstGeom prst="rect">
+            <a:avLst/>
+          </a:prstGeom>
+        </p:spPr>
+      </p:pic>
+    </p:spTree>
+    <p:extLst>
+      <p:ext uri="{BB962C8B-B14F-4D97-AF65-F5344CB8AC3E}">
+        <p14:creationId xmlns:p14="http://schemas.microsoft.com/office/powerpoint/2010/main" val="2809698228"/>
+      </p:ext>
+    </p:extLst>
+  </p:cSld>
+  <p:clrMapOvr>
+    <a:masterClrMapping/>
+  </p:clrMapOvr>
+</p:sld>
+</file>
+
+<file path=ppt/slides/slide9.xml><?xml version="1.0" encoding="utf-8"?>
+<p:sld xmlns:a="http://schemas.openxmlformats.org/drawingml/2006/main" xmlns:r="http://schemas.openxmlformats.org/officeDocument/2006/relationships" xmlns:p="http://schemas.openxmlformats.org/presentationml/2006/main">
+  <p:cSld>
+    <p:spTree>
+      <p:nvGrpSpPr>
+        <p:cNvPr id="1" name="">
+          <a:extLst>
+            <a:ext uri="{FF2B5EF4-FFF2-40B4-BE49-F238E27FC236}">
+              <a16:creationId xmlns:a16="http://schemas.microsoft.com/office/drawing/2014/main" id="{AA6CEBE6-05C8-63F5-E3FC-CEF1427A4E8B}"/>
+            </a:ext>
+          </a:extLst>
+        </p:cNvPr>
+        <p:cNvGrpSpPr/>
+        <p:nvPr/>
+      </p:nvGrpSpPr>
+      <p:grpSpPr>
+        <a:xfrm>
+          <a:off x="0" y="0"/>
+          <a:ext cx="0" cy="0"/>
+          <a:chOff x="0" y="0"/>
+          <a:chExt cx="0" cy="0"/>
+        </a:xfrm>
+      </p:grpSpPr>
+    </p:spTree>
+    <p:extLst>
+      <p:ext uri="{BB962C8B-B14F-4D97-AF65-F5344CB8AC3E}">
+        <p14:creationId xmlns:p14="http://schemas.microsoft.com/office/powerpoint/2010/main" val="1812630969"/>
       </p:ext>
     </p:extLst>
   </p:cSld>

</xml_diff>